<commit_message>
style: Architektur-Deck an EatEasy-Hausstil angleichen
Farbpalette, Typografie und Layout aus Projektidee.pdf uebernommen:
dunkelgruene Titelfolie mit gesperrtem Kicker + Meta-Block, gruene
Section-Linien unter den Headings, gedaempfter Footer (Folie X / 7).

Co-Authored-By: Claude Opus 4.8 (1M context) <noreply@anthropic.com>
Claude-Session: https://claude.ai/code/session_01UMhECF8MTyHP6rFM1ZeaDP
</commit_message>
<xml_diff>
--- a/EatEasy-Architektur.pptx
+++ b/EatEasy-Architektur.pptx
@@ -3090,7 +3090,7 @@
     <p:bg>
       <p:bgPr>
         <a:solidFill>
-          <a:srgbClr val="1F2D3D"/>
+          <a:srgbClr val="1E3A2F"/>
         </a:solidFill>
         <a:effectLst/>
       </p:bgPr>
@@ -3104,14 +3104,57 @@
       <p:grpSpPr/>
       <p:sp>
         <p:nvSpPr>
-          <p:cNvPr id="2" name="TextBox 1"/>
+          <p:cNvPr id="2" name="Rectangle 1"/>
+          <p:cNvSpPr/>
+          <p:nvPr/>
+        </p:nvSpPr>
+        <p:spPr>
+          <a:xfrm>
+            <a:off x="0" y="0"/>
+            <a:ext cx="12191695" cy="292608"/>
+          </a:xfrm>
+          <a:prstGeom prst="rect">
+            <a:avLst/>
+          </a:prstGeom>
+          <a:solidFill>
+            <a:srgbClr val="2D5A47"/>
+          </a:solidFill>
+          <a:ln>
+            <a:noFill/>
+          </a:ln>
+        </p:spPr>
+        <p:style>
+          <a:lnRef idx="1">
+            <a:schemeClr val="accent1"/>
+          </a:lnRef>
+          <a:fillRef idx="3">
+            <a:schemeClr val="accent1"/>
+          </a:fillRef>
+          <a:effectRef idx="2">
+            <a:schemeClr val="accent1"/>
+          </a:effectRef>
+          <a:fontRef idx="minor">
+            <a:schemeClr val="lt1"/>
+          </a:fontRef>
+        </p:style>
+        <p:txBody>
+          <a:bodyPr rtlCol="0" anchor="ctr"/>
+          <a:lstStyle/>
+          <a:p>
+            <a:pPr algn="ctr"/>
+          </a:p>
+        </p:txBody>
+      </p:sp>
+      <p:sp>
+        <p:nvSpPr>
+          <p:cNvPr id="3" name="TextBox 2"/>
           <p:cNvSpPr txBox="1"/>
           <p:nvPr/>
         </p:nvSpPr>
         <p:spPr>
           <a:xfrm>
-            <a:off x="731520" y="2194560"/>
-            <a:ext cx="10698480" cy="2286000"/>
+            <a:off x="822960" y="1920240"/>
+            <a:ext cx="10515600" cy="457200"/>
           </a:xfrm>
           <a:prstGeom prst="rect">
             <a:avLst/>
@@ -3119,28 +3162,224 @@
           <a:noFill/>
         </p:spPr>
         <p:txBody>
+          <a:bodyPr wrap="none">
+            <a:spAutoFit/>
+          </a:bodyPr>
+          <a:lstStyle/>
+          <a:p>
+            <a:r>
+              <a:rPr sz="1300">
+                <a:solidFill>
+                  <a:srgbClr val="9FB6A9"/>
+                </a:solidFill>
+                <a:latin typeface="Arial"/>
+              </a:rPr>
+              <a:t>K O M P O N E N T E N B A S I E R T E   S O F T W A R E E N T W I C K L U N G</a:t>
+            </a:r>
+          </a:p>
+        </p:txBody>
+      </p:sp>
+      <p:sp>
+        <p:nvSpPr>
+          <p:cNvPr id="4" name="TextBox 3"/>
+          <p:cNvSpPr txBox="1"/>
+          <p:nvPr/>
+        </p:nvSpPr>
+        <p:spPr>
+          <a:xfrm>
+            <a:off x="777240" y="2377440"/>
+            <a:ext cx="10607040" cy="1188720"/>
+          </a:xfrm>
+          <a:prstGeom prst="rect">
+            <a:avLst/>
+          </a:prstGeom>
+          <a:noFill/>
+        </p:spPr>
+        <p:txBody>
+          <a:bodyPr wrap="none">
+            <a:spAutoFit/>
+          </a:bodyPr>
+          <a:lstStyle/>
+          <a:p>
+            <a:r>
+              <a:rPr sz="5000" b="1">
+                <a:solidFill>
+                  <a:srgbClr val="FFFFFF"/>
+                </a:solidFill>
+                <a:latin typeface="Arial"/>
+              </a:rPr>
+              <a:t>EatEasy EE — Architektur</a:t>
+            </a:r>
+          </a:p>
+        </p:txBody>
+      </p:sp>
+      <p:sp>
+        <p:nvSpPr>
+          <p:cNvPr id="5" name="TextBox 4"/>
+          <p:cNvSpPr txBox="1"/>
+          <p:nvPr/>
+        </p:nvSpPr>
+        <p:spPr>
+          <a:xfrm>
+            <a:off x="822960" y="3566160"/>
+            <a:ext cx="10515600" cy="1097280"/>
+          </a:xfrm>
+          <a:prstGeom prst="rect">
+            <a:avLst/>
+          </a:prstGeom>
+          <a:noFill/>
+        </p:spPr>
+        <p:txBody>
           <a:bodyPr wrap="square">
             <a:spAutoFit/>
           </a:bodyPr>
           <a:lstStyle/>
           <a:p>
             <a:r>
-              <a:rPr sz="4400" b="1">
+              <a:rPr sz="2000">
+                <a:solidFill>
+                  <a:srgbClr val="C9D8CF"/>
+                </a:solidFill>
+                <a:latin typeface="Arial"/>
+              </a:rPr>
+              <a:t>Modularer Monolith · Vue 3 + Quarkus</a:t>
+            </a:r>
+          </a:p>
+          <a:p>
+            <a:r>
+              <a:rPr sz="2000">
+                <a:solidFill>
+                  <a:srgbClr val="C9D8CF"/>
+                </a:solidFill>
+                <a:latin typeface="Arial"/>
+              </a:rPr>
+              <a:t>Studienprojekt Gruppe 5</a:t>
+            </a:r>
+          </a:p>
+        </p:txBody>
+      </p:sp>
+      <p:sp>
+        <p:nvSpPr>
+          <p:cNvPr id="6" name="Rectangle 5"/>
+          <p:cNvSpPr/>
+          <p:nvPr/>
+        </p:nvSpPr>
+        <p:spPr>
+          <a:xfrm>
+            <a:off x="822960" y="5440680"/>
+            <a:ext cx="10545775" cy="12700"/>
+          </a:xfrm>
+          <a:prstGeom prst="rect">
+            <a:avLst/>
+          </a:prstGeom>
+          <a:solidFill>
+            <a:srgbClr val="2D5A47"/>
+          </a:solidFill>
+          <a:ln>
+            <a:noFill/>
+          </a:ln>
+        </p:spPr>
+        <p:style>
+          <a:lnRef idx="1">
+            <a:schemeClr val="accent1"/>
+          </a:lnRef>
+          <a:fillRef idx="3">
+            <a:schemeClr val="accent1"/>
+          </a:fillRef>
+          <a:effectRef idx="2">
+            <a:schemeClr val="accent1"/>
+          </a:effectRef>
+          <a:fontRef idx="minor">
+            <a:schemeClr val="lt1"/>
+          </a:fontRef>
+        </p:style>
+        <p:txBody>
+          <a:bodyPr rtlCol="0" anchor="ctr"/>
+          <a:lstStyle/>
+          <a:p>
+            <a:pPr algn="ctr"/>
+          </a:p>
+        </p:txBody>
+      </p:sp>
+      <p:sp>
+        <p:nvSpPr>
+          <p:cNvPr id="7" name="TextBox 6"/>
+          <p:cNvSpPr txBox="1"/>
+          <p:nvPr/>
+        </p:nvSpPr>
+        <p:spPr>
+          <a:xfrm>
+            <a:off x="822960" y="5623560"/>
+            <a:ext cx="10515600" cy="1097280"/>
+          </a:xfrm>
+          <a:prstGeom prst="rect">
+            <a:avLst/>
+          </a:prstGeom>
+          <a:noFill/>
+        </p:spPr>
+        <p:txBody>
+          <a:bodyPr wrap="square">
+            <a:spAutoFit/>
+          </a:bodyPr>
+          <a:lstStyle/>
+          <a:p>
+            <a:r>
+              <a:rPr sz="1200">
+                <a:solidFill>
+                  <a:srgbClr val="9FB6A9"/>
+                </a:solidFill>
+                <a:latin typeface="Arial"/>
+              </a:rPr>
+              <a:t>Thema         </a:t>
+            </a:r>
+            <a:r>
+              <a:rPr sz="1200">
                 <a:solidFill>
                   <a:srgbClr val="FFFFFF"/>
                 </a:solidFill>
-              </a:rPr>
-              <a:t>EatEasy EE — Architektur</a:t>
-            </a:r>
-          </a:p>
-          <a:p>
-            <a:r>
-              <a:rPr sz="2200">
-                <a:solidFill>
-                  <a:srgbClr val="BBD0C2"/>
-                </a:solidFill>
-              </a:rPr>
-              <a:t>Modularer Monolith · Vue 3 + Quarkus · Studienprojekt Gruppe 5</a:t>
+                <a:latin typeface="Arial"/>
+              </a:rPr>
+              <a:t>    Architekturüberblick &amp; Planung</a:t>
+            </a:r>
+          </a:p>
+          <a:p>
+            <a:r>
+              <a:rPr sz="1200">
+                <a:solidFill>
+                  <a:srgbClr val="9FB6A9"/>
+                </a:solidFill>
+                <a:latin typeface="Arial"/>
+              </a:rPr>
+              <a:t>Stack         </a:t>
+            </a:r>
+            <a:r>
+              <a:rPr sz="1200">
+                <a:solidFill>
+                  <a:srgbClr val="FFFFFF"/>
+                </a:solidFill>
+                <a:latin typeface="Arial"/>
+              </a:rPr>
+              <a:t>    Vue.js · Quarkus · PostgreSQL · Docker</a:t>
+            </a:r>
+          </a:p>
+          <a:p>
+            <a:r>
+              <a:rPr sz="1200">
+                <a:solidFill>
+                  <a:srgbClr val="9FB6A9"/>
+                </a:solidFill>
+                <a:latin typeface="Arial"/>
+              </a:rPr>
+              <a:t>Stand         </a:t>
+            </a:r>
+            <a:r>
+              <a:rPr sz="1200">
+                <a:solidFill>
+                  <a:srgbClr val="FFFFFF"/>
+                </a:solidFill>
+                <a:latin typeface="Arial"/>
+              </a:rPr>
+              <a:t>    Phasen 0–10 umgesetzt, Issues #3–#8 offen</a:t>
             </a:r>
           </a:p>
         </p:txBody>
@@ -3171,8 +3410,8 @@
         </p:nvSpPr>
         <p:spPr>
           <a:xfrm>
-            <a:off x="548640" y="320040"/>
-            <a:ext cx="11064240" cy="822960"/>
+            <a:off x="640080" y="365760"/>
+            <a:ext cx="10972800" cy="822960"/>
           </a:xfrm>
           <a:prstGeom prst="rect">
             <a:avLst/>
@@ -3186,10 +3425,20 @@
           <a:lstStyle/>
           <a:p>
             <a:r>
-              <a:rPr sz="3000" b="1">
-                <a:solidFill>
-                  <a:srgbClr val="1F2D3D"/>
-                </a:solidFill>
+              <a:rPr sz="2800" b="1">
+                <a:solidFill>
+                  <a:srgbClr val="2D5A47"/>
+                </a:solidFill>
+                <a:latin typeface="Arial"/>
+              </a:rPr>
+              <a:t>1  </a:t>
+            </a:r>
+            <a:r>
+              <a:rPr sz="2800" b="1">
+                <a:solidFill>
+                  <a:srgbClr val="1A1A1A"/>
+                </a:solidFill>
+                <a:latin typeface="Arial"/>
               </a:rPr>
               <a:t>Grundsatzentscheidungen</a:t>
             </a:r>
@@ -3204,14 +3453,14 @@
         </p:nvSpPr>
         <p:spPr>
           <a:xfrm>
-            <a:off x="594360" y="1143000"/>
-            <a:ext cx="2377440" cy="38100"/>
+            <a:off x="658368" y="1170432"/>
+            <a:ext cx="10893247" cy="25400"/>
           </a:xfrm>
           <a:prstGeom prst="rect">
             <a:avLst/>
           </a:prstGeom>
           <a:solidFill>
-            <a:srgbClr val="2E7D32"/>
+            <a:srgbClr val="2D5A47"/>
           </a:solidFill>
           <a:ln>
             <a:noFill/>
@@ -3247,8 +3496,8 @@
         </p:nvSpPr>
         <p:spPr>
           <a:xfrm>
-            <a:off x="640080" y="1371600"/>
-            <a:ext cx="10972800" cy="5029200"/>
+            <a:off x="685800" y="1417320"/>
+            <a:ext cx="10972800" cy="4754880"/>
           </a:xfrm>
           <a:prstGeom prst="rect">
             <a:avLst/>
@@ -3263,29 +3512,31 @@
           <a:p>
             <a:pPr>
               <a:spcAft>
-                <a:spcPts val="600"/>
+                <a:spcPts val="700"/>
               </a:spcAft>
             </a:pPr>
             <a:r>
-              <a:rPr sz="2000" b="1">
-                <a:solidFill>
-                  <a:srgbClr val="1F2D3D"/>
-                </a:solidFill>
-              </a:rPr>
-              <a:t>Architekturstil: Modularer Monolith</a:t>
+              <a:rPr sz="1800" b="1">
+                <a:solidFill>
+                  <a:srgbClr val="1A1A1A"/>
+                </a:solidFill>
+                <a:latin typeface="Arial"/>
+              </a:rPr>
+              <a:t>▪  Architekturstil: Modularer Monolith</a:t>
             </a:r>
           </a:p>
           <a:p>
             <a:pPr lvl="1">
               <a:spcAft>
-                <a:spcPts val="600"/>
+                <a:spcPts val="700"/>
               </a:spcAft>
             </a:pPr>
             <a:r>
-              <a:rPr sz="1800" b="0">
-                <a:solidFill>
-                  <a:srgbClr val="555555"/>
-                </a:solidFill>
+              <a:rPr sz="1600" b="0">
+                <a:solidFill>
+                  <a:srgbClr val="333333"/>
+                </a:solidFill>
+                <a:latin typeface="Arial"/>
               </a:rPr>
               <a:t>–  Fachliche Komponenten statt technischer Layer</a:t>
             </a:r>
@@ -3293,74 +3544,79 @@
           <a:p>
             <a:pPr lvl="1">
               <a:spcAft>
-                <a:spcPts val="600"/>
+                <a:spcPts val="700"/>
               </a:spcAft>
             </a:pPr>
             <a:r>
-              <a:rPr sz="1800" b="0">
-                <a:solidFill>
-                  <a:srgbClr val="555555"/>
-                </a:solidFill>
-              </a:rPr>
-              <a:t>–  Komponenten kommunizieren nur ueber Service-Interfaces (CDI), nie via REST</a:t>
+              <a:rPr sz="1600" b="0">
+                <a:solidFill>
+                  <a:srgbClr val="333333"/>
+                </a:solidFill>
+                <a:latin typeface="Arial"/>
+              </a:rPr>
+              <a:t>–  Kommunikation nur ueber Service-Interfaces (CDI), nie via REST</a:t>
             </a:r>
           </a:p>
           <a:p>
             <a:pPr>
               <a:spcAft>
-                <a:spcPts val="600"/>
+                <a:spcPts val="700"/>
               </a:spcAft>
             </a:pPr>
             <a:r>
-              <a:rPr sz="2000" b="1">
-                <a:solidFill>
-                  <a:srgbClr val="1F2D3D"/>
-                </a:solidFill>
-              </a:rPr>
-              <a:t>Strikte DTO-Trennung</a:t>
+              <a:rPr sz="1800" b="1">
+                <a:solidFill>
+                  <a:srgbClr val="1A1A1A"/>
+                </a:solidFill>
+                <a:latin typeface="Arial"/>
+              </a:rPr>
+              <a:t>▪  Strikte DTO-Trennung</a:t>
             </a:r>
           </a:p>
           <a:p>
             <a:pPr lvl="1">
               <a:spcAft>
-                <a:spcPts val="600"/>
+                <a:spcPts val="700"/>
               </a:spcAft>
             </a:pPr>
             <a:r>
-              <a:rPr sz="1800" b="0">
-                <a:solidFill>
-                  <a:srgbClr val="555555"/>
-                </a:solidFill>
-              </a:rPr>
-              <a:t>–  Entities lecken nie aus REST-Endpunkten; DTOs sind Java-Records mit Validation</a:t>
+              <a:rPr sz="1600" b="0">
+                <a:solidFill>
+                  <a:srgbClr val="333333"/>
+                </a:solidFill>
+                <a:latin typeface="Arial"/>
+              </a:rPr>
+              <a:t>–  Entities lecken nie aus REST-Endpunkten; DTOs sind Java-Records</a:t>
             </a:r>
           </a:p>
           <a:p>
             <a:pPr>
               <a:spcAft>
-                <a:spcPts val="600"/>
+                <a:spcPts val="700"/>
               </a:spcAft>
             </a:pPr>
             <a:r>
-              <a:rPr sz="2000" b="1">
-                <a:solidFill>
-                  <a:srgbClr val="1F2D3D"/>
-                </a:solidFill>
-              </a:rPr>
-              <a:t>Auth: Stateless JWT (8 h)</a:t>
+              <a:rPr sz="1800" b="1">
+                <a:solidFill>
+                  <a:srgbClr val="1A1A1A"/>
+                </a:solidFill>
+                <a:latin typeface="Arial"/>
+              </a:rPr>
+              <a:t>▪  Auth: Stateless JWT (8 h)</a:t>
             </a:r>
           </a:p>
           <a:p>
             <a:pPr lvl="1">
               <a:spcAft>
-                <a:spcPts val="600"/>
+                <a:spcPts val="700"/>
               </a:spcAft>
             </a:pPr>
             <a:r>
-              <a:rPr sz="1800" b="0">
-                <a:solidFill>
-                  <a:srgbClr val="555555"/>
-                </a:solidFill>
+              <a:rPr sz="1600" b="0">
+                <a:solidFill>
+                  <a:srgbClr val="333333"/>
+                </a:solidFill>
+                <a:latin typeface="Arial"/>
               </a:rPr>
               <a:t>–  @RolesAllowed plus Authorization-Checks im Service-Layer</a:t>
             </a:r>
@@ -3368,16 +3624,86 @@
           <a:p>
             <a:pPr>
               <a:spcAft>
-                <a:spcPts val="600"/>
+                <a:spcPts val="700"/>
               </a:spcAft>
             </a:pPr>
             <a:r>
-              <a:rPr sz="2000" b="1">
-                <a:solidFill>
-                  <a:srgbClr val="1F2D3D"/>
-                </a:solidFill>
-              </a:rPr>
-              <a:t>Daten: UUID v4 ueberall, Flyway-Migrationen, Hibernate = validate</a:t>
+              <a:rPr sz="1800" b="1">
+                <a:solidFill>
+                  <a:srgbClr val="1A1A1A"/>
+                </a:solidFill>
+                <a:latin typeface="Arial"/>
+              </a:rPr>
+              <a:t>▪  Daten: UUID v4, Flyway-Migrationen, Hibernate = validate</a:t>
+            </a:r>
+          </a:p>
+        </p:txBody>
+      </p:sp>
+      <p:sp>
+        <p:nvSpPr>
+          <p:cNvPr id="5" name="TextBox 4"/>
+          <p:cNvSpPr txBox="1"/>
+          <p:nvPr/>
+        </p:nvSpPr>
+        <p:spPr>
+          <a:xfrm>
+            <a:off x="640080" y="6400800"/>
+            <a:ext cx="5486400" cy="365760"/>
+          </a:xfrm>
+          <a:prstGeom prst="rect">
+            <a:avLst/>
+          </a:prstGeom>
+          <a:noFill/>
+        </p:spPr>
+        <p:txBody>
+          <a:bodyPr wrap="none">
+            <a:spAutoFit/>
+          </a:bodyPr>
+          <a:lstStyle/>
+          <a:p>
+            <a:r>
+              <a:rPr sz="900">
+                <a:solidFill>
+                  <a:srgbClr val="777777"/>
+                </a:solidFill>
+                <a:latin typeface="Arial"/>
+              </a:rPr>
+              <a:t>EatEasy EE — Architektur</a:t>
+            </a:r>
+          </a:p>
+        </p:txBody>
+      </p:sp>
+      <p:sp>
+        <p:nvSpPr>
+          <p:cNvPr id="6" name="TextBox 5"/>
+          <p:cNvSpPr txBox="1"/>
+          <p:nvPr/>
+        </p:nvSpPr>
+        <p:spPr>
+          <a:xfrm>
+            <a:off x="6400800" y="6400800"/>
+            <a:ext cx="5120640" cy="365760"/>
+          </a:xfrm>
+          <a:prstGeom prst="rect">
+            <a:avLst/>
+          </a:prstGeom>
+          <a:noFill/>
+        </p:spPr>
+        <p:txBody>
+          <a:bodyPr wrap="none">
+            <a:spAutoFit/>
+          </a:bodyPr>
+          <a:lstStyle/>
+          <a:p>
+            <a:pPr algn="r"/>
+            <a:r>
+              <a:rPr sz="900">
+                <a:solidFill>
+                  <a:srgbClr val="777777"/>
+                </a:solidFill>
+                <a:latin typeface="Arial"/>
+              </a:rPr>
+              <a:t>Folie 2 / 7</a:t>
             </a:r>
           </a:p>
         </p:txBody>
@@ -3408,8 +3734,8 @@
         </p:nvSpPr>
         <p:spPr>
           <a:xfrm>
-            <a:off x="548640" y="320040"/>
-            <a:ext cx="11064240" cy="822960"/>
+            <a:off x="640080" y="365760"/>
+            <a:ext cx="10972800" cy="822960"/>
           </a:xfrm>
           <a:prstGeom prst="rect">
             <a:avLst/>
@@ -3423,10 +3749,20 @@
           <a:lstStyle/>
           <a:p>
             <a:r>
-              <a:rPr sz="3000" b="1">
-                <a:solidFill>
-                  <a:srgbClr val="1F2D3D"/>
-                </a:solidFill>
+              <a:rPr sz="2800" b="1">
+                <a:solidFill>
+                  <a:srgbClr val="2D5A47"/>
+                </a:solidFill>
+                <a:latin typeface="Arial"/>
+              </a:rPr>
+              <a:t>2  </a:t>
+            </a:r>
+            <a:r>
+              <a:rPr sz="2800" b="1">
+                <a:solidFill>
+                  <a:srgbClr val="1A1A1A"/>
+                </a:solidFill>
+                <a:latin typeface="Arial"/>
               </a:rPr>
               <a:t>Komponenten &amp; Abhaengigkeiten</a:t>
             </a:r>
@@ -3441,14 +3777,14 @@
         </p:nvSpPr>
         <p:spPr>
           <a:xfrm>
-            <a:off x="594360" y="1143000"/>
-            <a:ext cx="2377440" cy="38100"/>
+            <a:off x="658368" y="1170432"/>
+            <a:ext cx="10893247" cy="25400"/>
           </a:xfrm>
           <a:prstGeom prst="rect">
             <a:avLst/>
           </a:prstGeom>
           <a:solidFill>
-            <a:srgbClr val="2E7D32"/>
+            <a:srgbClr val="2D5A47"/>
           </a:solidFill>
           <a:ln>
             <a:noFill/>
@@ -3484,8 +3820,8 @@
         </p:nvSpPr>
         <p:spPr>
           <a:xfrm>
-            <a:off x="640080" y="1371600"/>
-            <a:ext cx="10972800" cy="5029200"/>
+            <a:off x="685800" y="1417320"/>
+            <a:ext cx="10972800" cy="4754880"/>
           </a:xfrm>
           <a:prstGeom prst="rect">
             <a:avLst/>
@@ -3500,29 +3836,31 @@
           <a:p>
             <a:pPr>
               <a:spcAft>
-                <a:spcPts val="600"/>
+                <a:spcPts val="700"/>
               </a:spcAft>
             </a:pPr>
             <a:r>
-              <a:rPr sz="2000" b="1">
-                <a:solidFill>
-                  <a:srgbClr val="1F2D3D"/>
-                </a:solidFill>
-              </a:rPr>
-              <a:t>Backend (de.eateasy.*)</a:t>
+              <a:rPr sz="1800" b="1">
+                <a:solidFill>
+                  <a:srgbClr val="1A1A1A"/>
+                </a:solidFill>
+                <a:latin typeface="Arial"/>
+              </a:rPr>
+              <a:t>▪  Backend (de.eateasy.*)</a:t>
             </a:r>
           </a:p>
           <a:p>
             <a:pPr lvl="1">
               <a:spcAft>
-                <a:spcPts val="600"/>
+                <a:spcPts val="700"/>
               </a:spcAft>
             </a:pPr>
             <a:r>
-              <a:rPr sz="1800" b="0">
-                <a:solidFill>
-                  <a:srgbClr val="555555"/>
-                </a:solidFill>
+              <a:rPr sz="1600" b="0">
+                <a:solidFill>
+                  <a:srgbClr val="333333"/>
+                </a:solidFill>
+                <a:latin typeface="Arial"/>
               </a:rPr>
               <a:t>–  auth · household · recipe · ingredient · mealplan</a:t>
             </a:r>
@@ -3530,14 +3868,15 @@
           <a:p>
             <a:pPr lvl="1">
               <a:spcAft>
-                <a:spcPts val="600"/>
+                <a:spcPts val="700"/>
               </a:spcAft>
             </a:pPr>
             <a:r>
-              <a:rPr sz="1800" b="0">
-                <a:solidFill>
-                  <a:srgbClr val="555555"/>
-                </a:solidFill>
+              <a:rPr sz="1600" b="0">
+                <a:solidFill>
+                  <a:srgbClr val="333333"/>
+                </a:solidFill>
+                <a:latin typeface="Arial"/>
               </a:rPr>
               <a:t>–  pantry · shoppinglist · suggestion · integration · notification · common</a:t>
             </a:r>
@@ -3545,29 +3884,31 @@
           <a:p>
             <a:pPr>
               <a:spcAft>
-                <a:spcPts val="600"/>
+                <a:spcPts val="700"/>
               </a:spcAft>
             </a:pPr>
             <a:r>
-              <a:rPr sz="2000" b="1">
-                <a:solidFill>
-                  <a:srgbClr val="1F2D3D"/>
-                </a:solidFill>
-              </a:rPr>
-              <a:t>Schichten je Komponente</a:t>
+              <a:rPr sz="1800" b="1">
+                <a:solidFill>
+                  <a:srgbClr val="1A1A1A"/>
+                </a:solidFill>
+                <a:latin typeface="Arial"/>
+              </a:rPr>
+              <a:t>▪  Schichten je Komponente</a:t>
             </a:r>
           </a:p>
           <a:p>
             <a:pPr lvl="1">
               <a:spcAft>
-                <a:spcPts val="600"/>
+                <a:spcPts val="700"/>
               </a:spcAft>
             </a:pPr>
             <a:r>
-              <a:rPr sz="1800" b="0">
-                <a:solidFill>
-                  <a:srgbClr val="555555"/>
-                </a:solidFill>
+              <a:rPr sz="1600" b="0">
+                <a:solidFill>
+                  <a:srgbClr val="333333"/>
+                </a:solidFill>
+                <a:latin typeface="Arial"/>
               </a:rPr>
               <a:t>–  entity -&gt; repository -&gt; service (Interface+Impl) -&gt; resource -&gt; dto</a:t>
             </a:r>
@@ -3575,29 +3916,31 @@
           <a:p>
             <a:pPr>
               <a:spcAft>
-                <a:spcPts val="600"/>
+                <a:spcPts val="700"/>
               </a:spcAft>
             </a:pPr>
             <a:r>
-              <a:rPr sz="2000" b="1">
-                <a:solidFill>
-                  <a:srgbClr val="1F2D3D"/>
-                </a:solidFill>
-              </a:rPr>
-              <a:t>Abhaengigkeitsfluss</a:t>
+              <a:rPr sz="1800" b="1">
+                <a:solidFill>
+                  <a:srgbClr val="1A1A1A"/>
+                </a:solidFill>
+                <a:latin typeface="Arial"/>
+              </a:rPr>
+              <a:t>▪  Abhaengigkeitsfluss</a:t>
             </a:r>
           </a:p>
           <a:p>
             <a:pPr lvl="1">
               <a:spcAft>
-                <a:spcPts val="600"/>
+                <a:spcPts val="700"/>
               </a:spcAft>
             </a:pPr>
             <a:r>
-              <a:rPr sz="1800" b="0">
-                <a:solidFill>
-                  <a:srgbClr val="555555"/>
-                </a:solidFill>
+              <a:rPr sz="1600" b="0">
+                <a:solidFill>
+                  <a:srgbClr val="333333"/>
+                </a:solidFill>
+                <a:latin typeface="Arial"/>
               </a:rPr>
               <a:t>–  auth -&gt; household -&gt; (recipe, pantry) -&gt; mealplan -&gt; shoppinglist -&gt; suggestion</a:t>
             </a:r>
@@ -3605,16 +3948,86 @@
           <a:p>
             <a:pPr lvl="1">
               <a:spcAft>
-                <a:spcPts val="600"/>
+                <a:spcPts val="700"/>
               </a:spcAft>
             </a:pPr>
             <a:r>
-              <a:rPr sz="1800" b="0">
-                <a:solidFill>
-                  <a:srgbClr val="555555"/>
-                </a:solidFill>
-              </a:rPr>
-              <a:t>–  notification an household (Einladungen); integration speist recipe &amp; pantry</a:t>
+              <a:rPr sz="1600" b="0">
+                <a:solidFill>
+                  <a:srgbClr val="333333"/>
+                </a:solidFill>
+                <a:latin typeface="Arial"/>
+              </a:rPr>
+              <a:t>–  notification an household; integration speist recipe &amp; pantry</a:t>
+            </a:r>
+          </a:p>
+        </p:txBody>
+      </p:sp>
+      <p:sp>
+        <p:nvSpPr>
+          <p:cNvPr id="5" name="TextBox 4"/>
+          <p:cNvSpPr txBox="1"/>
+          <p:nvPr/>
+        </p:nvSpPr>
+        <p:spPr>
+          <a:xfrm>
+            <a:off x="640080" y="6400800"/>
+            <a:ext cx="5486400" cy="365760"/>
+          </a:xfrm>
+          <a:prstGeom prst="rect">
+            <a:avLst/>
+          </a:prstGeom>
+          <a:noFill/>
+        </p:spPr>
+        <p:txBody>
+          <a:bodyPr wrap="none">
+            <a:spAutoFit/>
+          </a:bodyPr>
+          <a:lstStyle/>
+          <a:p>
+            <a:r>
+              <a:rPr sz="900">
+                <a:solidFill>
+                  <a:srgbClr val="777777"/>
+                </a:solidFill>
+                <a:latin typeface="Arial"/>
+              </a:rPr>
+              <a:t>EatEasy EE — Architektur</a:t>
+            </a:r>
+          </a:p>
+        </p:txBody>
+      </p:sp>
+      <p:sp>
+        <p:nvSpPr>
+          <p:cNvPr id="6" name="TextBox 5"/>
+          <p:cNvSpPr txBox="1"/>
+          <p:nvPr/>
+        </p:nvSpPr>
+        <p:spPr>
+          <a:xfrm>
+            <a:off x="6400800" y="6400800"/>
+            <a:ext cx="5120640" cy="365760"/>
+          </a:xfrm>
+          <a:prstGeom prst="rect">
+            <a:avLst/>
+          </a:prstGeom>
+          <a:noFill/>
+        </p:spPr>
+        <p:txBody>
+          <a:bodyPr wrap="none">
+            <a:spAutoFit/>
+          </a:bodyPr>
+          <a:lstStyle/>
+          <a:p>
+            <a:pPr algn="r"/>
+            <a:r>
+              <a:rPr sz="900">
+                <a:solidFill>
+                  <a:srgbClr val="777777"/>
+                </a:solidFill>
+                <a:latin typeface="Arial"/>
+              </a:rPr>
+              <a:t>Folie 3 / 7</a:t>
             </a:r>
           </a:p>
         </p:txBody>
@@ -3645,8 +4058,8 @@
         </p:nvSpPr>
         <p:spPr>
           <a:xfrm>
-            <a:off x="548640" y="320040"/>
-            <a:ext cx="11064240" cy="822960"/>
+            <a:off x="640080" y="365760"/>
+            <a:ext cx="10972800" cy="822960"/>
           </a:xfrm>
           <a:prstGeom prst="rect">
             <a:avLst/>
@@ -3660,10 +4073,20 @@
           <a:lstStyle/>
           <a:p>
             <a:r>
-              <a:rPr sz="3000" b="1">
-                <a:solidFill>
-                  <a:srgbClr val="1F2D3D"/>
-                </a:solidFill>
+              <a:rPr sz="2800" b="1">
+                <a:solidFill>
+                  <a:srgbClr val="2D5A47"/>
+                </a:solidFill>
+                <a:latin typeface="Arial"/>
+              </a:rPr>
+              <a:t>3  </a:t>
+            </a:r>
+            <a:r>
+              <a:rPr sz="2800" b="1">
+                <a:solidFill>
+                  <a:srgbClr val="1A1A1A"/>
+                </a:solidFill>
+                <a:latin typeface="Arial"/>
               </a:rPr>
               <a:t>Genutzte Technologien</a:t>
             </a:r>
@@ -3678,14 +4101,14 @@
         </p:nvSpPr>
         <p:spPr>
           <a:xfrm>
-            <a:off x="594360" y="1143000"/>
-            <a:ext cx="2377440" cy="38100"/>
+            <a:off x="658368" y="1170432"/>
+            <a:ext cx="10893247" cy="25400"/>
           </a:xfrm>
           <a:prstGeom prst="rect">
             <a:avLst/>
           </a:prstGeom>
           <a:solidFill>
-            <a:srgbClr val="2E7D32"/>
+            <a:srgbClr val="2D5A47"/>
           </a:solidFill>
           <a:ln>
             <a:noFill/>
@@ -3721,8 +4144,8 @@
         </p:nvSpPr>
         <p:spPr>
           <a:xfrm>
-            <a:off x="640080" y="1371600"/>
-            <a:ext cx="10972800" cy="5029200"/>
+            <a:off x="685800" y="1417320"/>
+            <a:ext cx="10972800" cy="4754880"/>
           </a:xfrm>
           <a:prstGeom prst="rect">
             <a:avLst/>
@@ -3737,121 +4160,198 @@
           <a:p>
             <a:pPr>
               <a:spcAft>
-                <a:spcPts val="600"/>
+                <a:spcPts val="700"/>
               </a:spcAft>
             </a:pPr>
             <a:r>
-              <a:rPr sz="2000" b="1">
-                <a:solidFill>
-                  <a:srgbClr val="1F2D3D"/>
-                </a:solidFill>
-              </a:rPr>
-              <a:t>Frontend: Vue 3, Vite, Pinia, Vue Router, TypeScript (strict), Tailwind, VueUse</a:t>
+              <a:rPr sz="1800" b="1">
+                <a:solidFill>
+                  <a:srgbClr val="1A1A1A"/>
+                </a:solidFill>
+                <a:latin typeface="Arial"/>
+              </a:rPr>
+              <a:t>▪  Frontend: Vue 3, Vite, Pinia, Vue Router, TypeScript, Tailwind, VueUse</a:t>
             </a:r>
           </a:p>
           <a:p>
             <a:pPr>
               <a:spcAft>
-                <a:spcPts val="600"/>
+                <a:spcPts val="700"/>
               </a:spcAft>
             </a:pPr>
             <a:r>
-              <a:rPr sz="2000" b="1">
-                <a:solidFill>
-                  <a:srgbClr val="1F2D3D"/>
-                </a:solidFill>
-              </a:rPr>
-              <a:t>Backend: Quarkus (Java 21), RESTEasy Reactive, Hibernate Panache, SmallRye JWT, Mailer</a:t>
+              <a:rPr sz="1800" b="1">
+                <a:solidFill>
+                  <a:srgbClr val="1A1A1A"/>
+                </a:solidFill>
+                <a:latin typeface="Arial"/>
+              </a:rPr>
+              <a:t>▪  Backend: Quarkus (Java 21), RESTEasy Reactive, Hibernate Panache, SmallRye JWT</a:t>
             </a:r>
           </a:p>
           <a:p>
             <a:pPr>
               <a:spcAft>
-                <a:spcPts val="600"/>
+                <a:spcPts val="700"/>
               </a:spcAft>
             </a:pPr>
             <a:r>
-              <a:rPr sz="2000" b="1">
-                <a:solidFill>
-                  <a:srgbClr val="1F2D3D"/>
-                </a:solidFill>
-              </a:rPr>
-              <a:t>Datenbank: PostgreSQL 16 + Flyway</a:t>
+              <a:rPr sz="1800" b="1">
+                <a:solidFill>
+                  <a:srgbClr val="1A1A1A"/>
+                </a:solidFill>
+                <a:latin typeface="Arial"/>
+              </a:rPr>
+              <a:t>▪  Datenbank: PostgreSQL 16 + Flyway</a:t>
             </a:r>
           </a:p>
           <a:p>
             <a:pPr>
               <a:spcAft>
-                <a:spcPts val="600"/>
+                <a:spcPts val="700"/>
               </a:spcAft>
             </a:pPr>
             <a:r>
-              <a:rPr sz="2000" b="1">
-                <a:solidFill>
-                  <a:srgbClr val="1F2D3D"/>
-                </a:solidFill>
-              </a:rPr>
-              <a:t>LLM: Ollama self-hosted (Llama 3 / Mistral)</a:t>
+              <a:rPr sz="1800" b="1">
+                <a:solidFill>
+                  <a:srgbClr val="1A1A1A"/>
+                </a:solidFill>
+                <a:latin typeface="Arial"/>
+              </a:rPr>
+              <a:t>▪  LLM: Ollama self-hosted (Llama 3 / Mistral)</a:t>
             </a:r>
           </a:p>
           <a:p>
             <a:pPr>
               <a:spcAft>
-                <a:spcPts val="600"/>
+                <a:spcPts val="700"/>
               </a:spcAft>
             </a:pPr>
             <a:r>
-              <a:rPr sz="2000" b="1">
-                <a:solidFill>
-                  <a:srgbClr val="1F2D3D"/>
-                </a:solidFill>
-              </a:rPr>
-              <a:t>Externe APIs: TheMealDB (Rezepte), OpenFoodFacts (Barcode)</a:t>
+              <a:rPr sz="1800" b="1">
+                <a:solidFill>
+                  <a:srgbClr val="1A1A1A"/>
+                </a:solidFill>
+                <a:latin typeface="Arial"/>
+              </a:rPr>
+              <a:t>▪  Externe APIs: TheMealDB (Rezepte), OpenFoodFacts (Barcode)</a:t>
             </a:r>
           </a:p>
           <a:p>
             <a:pPr>
               <a:spcAft>
-                <a:spcPts val="600"/>
+                <a:spcPts val="700"/>
               </a:spcAft>
             </a:pPr>
             <a:r>
-              <a:rPr sz="2000" b="1">
-                <a:solidFill>
-                  <a:srgbClr val="1F2D3D"/>
-                </a:solidFill>
-              </a:rPr>
-              <a:t>Testing: JUnit5 + REST Assured, Vitest + MSW, Playwright (E2E)</a:t>
+              <a:rPr sz="1800" b="1">
+                <a:solidFill>
+                  <a:srgbClr val="1A1A1A"/>
+                </a:solidFill>
+                <a:latin typeface="Arial"/>
+              </a:rPr>
+              <a:t>▪  Testing: JUnit5 + REST Assured, Vitest + MSW, Playwright (E2E)</a:t>
             </a:r>
           </a:p>
           <a:p>
             <a:pPr>
               <a:spcAft>
-                <a:spcPts val="600"/>
+                <a:spcPts val="700"/>
               </a:spcAft>
             </a:pPr>
             <a:r>
-              <a:rPr sz="2000" b="1">
-                <a:solidFill>
-                  <a:srgbClr val="1F2D3D"/>
-                </a:solidFill>
-              </a:rPr>
-              <a:t>Qualitaet/CI: Checkstyle, ESLint + Prettier, GitHub Actions</a:t>
+              <a:rPr sz="1800" b="1">
+                <a:solidFill>
+                  <a:srgbClr val="1A1A1A"/>
+                </a:solidFill>
+                <a:latin typeface="Arial"/>
+              </a:rPr>
+              <a:t>▪  Qualitaet/CI: Checkstyle, ESLint + Prettier, GitHub Actions</a:t>
             </a:r>
           </a:p>
           <a:p>
             <a:pPr>
               <a:spcAft>
-                <a:spcPts val="600"/>
+                <a:spcPts val="700"/>
               </a:spcAft>
             </a:pPr>
             <a:r>
-              <a:rPr sz="2000" b="1">
-                <a:solidFill>
-                  <a:srgbClr val="1F2D3D"/>
-                </a:solidFill>
-              </a:rPr>
-              <a:t>Deployment: Render (Backend + DB), Vercel (Frontend, geplant)</a:t>
+              <a:rPr sz="1800" b="1">
+                <a:solidFill>
+                  <a:srgbClr val="1A1A1A"/>
+                </a:solidFill>
+                <a:latin typeface="Arial"/>
+              </a:rPr>
+              <a:t>▪  Deployment: Render (Backend + DB), Vercel (Frontend, geplant)</a:t>
+            </a:r>
+          </a:p>
+        </p:txBody>
+      </p:sp>
+      <p:sp>
+        <p:nvSpPr>
+          <p:cNvPr id="5" name="TextBox 4"/>
+          <p:cNvSpPr txBox="1"/>
+          <p:nvPr/>
+        </p:nvSpPr>
+        <p:spPr>
+          <a:xfrm>
+            <a:off x="640080" y="6400800"/>
+            <a:ext cx="5486400" cy="365760"/>
+          </a:xfrm>
+          <a:prstGeom prst="rect">
+            <a:avLst/>
+          </a:prstGeom>
+          <a:noFill/>
+        </p:spPr>
+        <p:txBody>
+          <a:bodyPr wrap="none">
+            <a:spAutoFit/>
+          </a:bodyPr>
+          <a:lstStyle/>
+          <a:p>
+            <a:r>
+              <a:rPr sz="900">
+                <a:solidFill>
+                  <a:srgbClr val="777777"/>
+                </a:solidFill>
+                <a:latin typeface="Arial"/>
+              </a:rPr>
+              <a:t>EatEasy EE — Architektur</a:t>
+            </a:r>
+          </a:p>
+        </p:txBody>
+      </p:sp>
+      <p:sp>
+        <p:nvSpPr>
+          <p:cNvPr id="6" name="TextBox 5"/>
+          <p:cNvSpPr txBox="1"/>
+          <p:nvPr/>
+        </p:nvSpPr>
+        <p:spPr>
+          <a:xfrm>
+            <a:off x="6400800" y="6400800"/>
+            <a:ext cx="5120640" cy="365760"/>
+          </a:xfrm>
+          <a:prstGeom prst="rect">
+            <a:avLst/>
+          </a:prstGeom>
+          <a:noFill/>
+        </p:spPr>
+        <p:txBody>
+          <a:bodyPr wrap="none">
+            <a:spAutoFit/>
+          </a:bodyPr>
+          <a:lstStyle/>
+          <a:p>
+            <a:pPr algn="r"/>
+            <a:r>
+              <a:rPr sz="900">
+                <a:solidFill>
+                  <a:srgbClr val="777777"/>
+                </a:solidFill>
+                <a:latin typeface="Arial"/>
+              </a:rPr>
+              <a:t>Folie 4 / 7</a:t>
             </a:r>
           </a:p>
         </p:txBody>
@@ -3882,8 +4382,8 @@
         </p:nvSpPr>
         <p:spPr>
           <a:xfrm>
-            <a:off x="548640" y="320040"/>
-            <a:ext cx="11064240" cy="822960"/>
+            <a:off x="640080" y="365760"/>
+            <a:ext cx="10972800" cy="822960"/>
           </a:xfrm>
           <a:prstGeom prst="rect">
             <a:avLst/>
@@ -3897,10 +4397,20 @@
           <a:lstStyle/>
           <a:p>
             <a:r>
-              <a:rPr sz="3000" b="1">
-                <a:solidFill>
-                  <a:srgbClr val="1F2D3D"/>
-                </a:solidFill>
+              <a:rPr sz="2800" b="1">
+                <a:solidFill>
+                  <a:srgbClr val="2D5A47"/>
+                </a:solidFill>
+                <a:latin typeface="Arial"/>
+              </a:rPr>
+              <a:t>4  </a:t>
+            </a:r>
+            <a:r>
+              <a:rPr sz="2800" b="1">
+                <a:solidFill>
+                  <a:srgbClr val="1A1A1A"/>
+                </a:solidFill>
+                <a:latin typeface="Arial"/>
               </a:rPr>
               <a:t>Resilienz / Backup-Plan</a:t>
             </a:r>
@@ -3915,14 +4425,14 @@
         </p:nvSpPr>
         <p:spPr>
           <a:xfrm>
-            <a:off x="594360" y="1143000"/>
-            <a:ext cx="2377440" cy="38100"/>
+            <a:off x="658368" y="1170432"/>
+            <a:ext cx="10893247" cy="25400"/>
           </a:xfrm>
           <a:prstGeom prst="rect">
             <a:avLst/>
           </a:prstGeom>
           <a:solidFill>
-            <a:srgbClr val="2E7D32"/>
+            <a:srgbClr val="2D5A47"/>
           </a:solidFill>
           <a:ln>
             <a:noFill/>
@@ -3958,8 +4468,8 @@
         </p:nvSpPr>
         <p:spPr>
           <a:xfrm>
-            <a:off x="640080" y="1371600"/>
-            <a:ext cx="10972800" cy="5029200"/>
+            <a:off x="685800" y="1417320"/>
+            <a:ext cx="10972800" cy="4754880"/>
           </a:xfrm>
           <a:prstGeom prst="rect">
             <a:avLst/>
@@ -3974,61 +4484,134 @@
           <a:p>
             <a:pPr>
               <a:spcAft>
-                <a:spcPts val="600"/>
+                <a:spcPts val="700"/>
               </a:spcAft>
             </a:pPr>
             <a:r>
-              <a:rPr sz="2000" b="1">
-                <a:solidFill>
-                  <a:srgbClr val="1F2D3D"/>
-                </a:solidFill>
-              </a:rPr>
-              <a:t>Smart-Suggestion: Ollama-Ausfall -&gt; Coverage-Heuristik (App bleibt nutzbar)</a:t>
+              <a:rPr sz="1800" b="1">
+                <a:solidFill>
+                  <a:srgbClr val="1A1A1A"/>
+                </a:solidFill>
+                <a:latin typeface="Arial"/>
+              </a:rPr>
+              <a:t>▪  Smart-Suggestion: Ollama-Ausfall -&gt; Coverage-Heuristik</a:t>
             </a:r>
           </a:p>
           <a:p>
             <a:pPr>
               <a:spcAft>
-                <a:spcPts val="600"/>
+                <a:spcPts val="700"/>
               </a:spcAft>
             </a:pPr>
             <a:r>
-              <a:rPr sz="2000" b="1">
-                <a:solidFill>
-                  <a:srgbClr val="1F2D3D"/>
-                </a:solidFill>
-              </a:rPr>
-              <a:t>Barcode-Scan: keine Kamera -&gt; manuelle Eingabe (Feature optional)</a:t>
+              <a:rPr sz="1800" b="1">
+                <a:solidFill>
+                  <a:srgbClr val="1A1A1A"/>
+                </a:solidFill>
+                <a:latin typeface="Arial"/>
+              </a:rPr>
+              <a:t>▪  Barcode-Scan: keine Kamera -&gt; manuelle Eingabe (optional)</a:t>
             </a:r>
           </a:p>
           <a:p>
             <a:pPr>
               <a:spcAft>
-                <a:spcPts val="600"/>
+                <a:spcPts val="700"/>
               </a:spcAft>
             </a:pPr>
             <a:r>
-              <a:rPr sz="2000" b="1">
-                <a:solidFill>
-                  <a:srgbClr val="1F2D3D"/>
-                </a:solidFill>
-              </a:rPr>
-              <a:t>Rezept-Import: nur TheMealDB (kostenlos, kein API-Key noetig)</a:t>
+              <a:rPr sz="1800" b="1">
+                <a:solidFill>
+                  <a:srgbClr val="1A1A1A"/>
+                </a:solidFill>
+                <a:latin typeface="Arial"/>
+              </a:rPr>
+              <a:t>▪  Rezept-Import: nur TheMealDB (kostenlos, kein API-Key)</a:t>
             </a:r>
           </a:p>
           <a:p>
             <a:pPr>
               <a:spcAft>
-                <a:spcPts val="600"/>
+                <a:spcPts val="700"/>
               </a:spcAft>
             </a:pPr>
             <a:r>
-              <a:rPr sz="2000" b="1">
-                <a:solidFill>
-                  <a:srgbClr val="1F2D3D"/>
-                </a:solidFill>
-              </a:rPr>
-              <a:t>E-Mail: Maildev/SMTP; Invitation wird auch bei Mail-Fehler angelegt</a:t>
+              <a:rPr sz="1800" b="1">
+                <a:solidFill>
+                  <a:srgbClr val="1A1A1A"/>
+                </a:solidFill>
+                <a:latin typeface="Arial"/>
+              </a:rPr>
+              <a:t>▪  E-Mail: Invitation wird auch bei Mail-Fehler angelegt</a:t>
+            </a:r>
+          </a:p>
+        </p:txBody>
+      </p:sp>
+      <p:sp>
+        <p:nvSpPr>
+          <p:cNvPr id="5" name="TextBox 4"/>
+          <p:cNvSpPr txBox="1"/>
+          <p:nvPr/>
+        </p:nvSpPr>
+        <p:spPr>
+          <a:xfrm>
+            <a:off x="640080" y="6400800"/>
+            <a:ext cx="5486400" cy="365760"/>
+          </a:xfrm>
+          <a:prstGeom prst="rect">
+            <a:avLst/>
+          </a:prstGeom>
+          <a:noFill/>
+        </p:spPr>
+        <p:txBody>
+          <a:bodyPr wrap="none">
+            <a:spAutoFit/>
+          </a:bodyPr>
+          <a:lstStyle/>
+          <a:p>
+            <a:r>
+              <a:rPr sz="900">
+                <a:solidFill>
+                  <a:srgbClr val="777777"/>
+                </a:solidFill>
+                <a:latin typeface="Arial"/>
+              </a:rPr>
+              <a:t>EatEasy EE — Architektur</a:t>
+            </a:r>
+          </a:p>
+        </p:txBody>
+      </p:sp>
+      <p:sp>
+        <p:nvSpPr>
+          <p:cNvPr id="6" name="TextBox 5"/>
+          <p:cNvSpPr txBox="1"/>
+          <p:nvPr/>
+        </p:nvSpPr>
+        <p:spPr>
+          <a:xfrm>
+            <a:off x="6400800" y="6400800"/>
+            <a:ext cx="5120640" cy="365760"/>
+          </a:xfrm>
+          <a:prstGeom prst="rect">
+            <a:avLst/>
+          </a:prstGeom>
+          <a:noFill/>
+        </p:spPr>
+        <p:txBody>
+          <a:bodyPr wrap="none">
+            <a:spAutoFit/>
+          </a:bodyPr>
+          <a:lstStyle/>
+          <a:p>
+            <a:pPr algn="r"/>
+            <a:r>
+              <a:rPr sz="900">
+                <a:solidFill>
+                  <a:srgbClr val="777777"/>
+                </a:solidFill>
+                <a:latin typeface="Arial"/>
+              </a:rPr>
+              <a:t>Folie 5 / 7</a:t>
             </a:r>
           </a:p>
         </p:txBody>
@@ -4059,8 +4642,8 @@
         </p:nvSpPr>
         <p:spPr>
           <a:xfrm>
-            <a:off x="548640" y="320040"/>
-            <a:ext cx="11064240" cy="822960"/>
+            <a:off x="640080" y="365760"/>
+            <a:ext cx="10972800" cy="822960"/>
           </a:xfrm>
           <a:prstGeom prst="rect">
             <a:avLst/>
@@ -4074,12 +4657,22 @@
           <a:lstStyle/>
           <a:p>
             <a:r>
-              <a:rPr sz="3000" b="1">
-                <a:solidFill>
-                  <a:srgbClr val="1F2D3D"/>
-                </a:solidFill>
-              </a:rPr>
-              <a:t>Was wir noch planen (Issues #3-#8)</a:t>
+              <a:rPr sz="2800" b="1">
+                <a:solidFill>
+                  <a:srgbClr val="2D5A47"/>
+                </a:solidFill>
+                <a:latin typeface="Arial"/>
+              </a:rPr>
+              <a:t>5  </a:t>
+            </a:r>
+            <a:r>
+              <a:rPr sz="2800" b="1">
+                <a:solidFill>
+                  <a:srgbClr val="1A1A1A"/>
+                </a:solidFill>
+                <a:latin typeface="Arial"/>
+              </a:rPr>
+              <a:t>Was wir noch planen (Issues #3–#8)</a:t>
             </a:r>
           </a:p>
         </p:txBody>
@@ -4092,14 +4685,14 @@
         </p:nvSpPr>
         <p:spPr>
           <a:xfrm>
-            <a:off x="594360" y="1143000"/>
-            <a:ext cx="2377440" cy="38100"/>
+            <a:off x="658368" y="1170432"/>
+            <a:ext cx="10893247" cy="25400"/>
           </a:xfrm>
           <a:prstGeom prst="rect">
             <a:avLst/>
           </a:prstGeom>
           <a:solidFill>
-            <a:srgbClr val="2E7D32"/>
+            <a:srgbClr val="2D5A47"/>
           </a:solidFill>
           <a:ln>
             <a:noFill/>
@@ -4135,8 +4728,8 @@
         </p:nvSpPr>
         <p:spPr>
           <a:xfrm>
-            <a:off x="640080" y="1371600"/>
-            <a:ext cx="10972800" cy="5029200"/>
+            <a:off x="685800" y="1417320"/>
+            <a:ext cx="10972800" cy="4754880"/>
           </a:xfrm>
           <a:prstGeom prst="rect">
             <a:avLst/>
@@ -4151,121 +4744,182 @@
           <a:p>
             <a:pPr>
               <a:spcAft>
-                <a:spcPts val="600"/>
+                <a:spcPts val="700"/>
               </a:spcAft>
             </a:pPr>
             <a:r>
-              <a:rPr sz="2000" b="1">
-                <a:solidFill>
-                  <a:srgbClr val="1F2D3D"/>
-                </a:solidFill>
-              </a:rPr>
-              <a:t>#3 Auto-Haushalt bei Registrierung</a:t>
+              <a:rPr sz="1800" b="1">
+                <a:solidFill>
+                  <a:srgbClr val="1A1A1A"/>
+                </a:solidFill>
+                <a:latin typeface="Arial"/>
+              </a:rPr>
+              <a:t>▪  #3 Auto-Haushalt bei Registrierung</a:t>
             </a:r>
           </a:p>
           <a:p>
             <a:pPr lvl="1">
               <a:spcAft>
-                <a:spcPts val="600"/>
+                <a:spcPts val="700"/>
               </a:spcAft>
             </a:pPr>
             <a:r>
-              <a:rPr sz="1800" b="0">
-                <a:solidFill>
-                  <a:srgbClr val="555555"/>
-                </a:solidFill>
-              </a:rPr>
-              <a:t>–  AuthService injiziert HouseholdService, eine @Transactional-Einheit (kein Schema)</a:t>
+              <a:rPr sz="1600" b="0">
+                <a:solidFill>
+                  <a:srgbClr val="333333"/>
+                </a:solidFill>
+                <a:latin typeface="Arial"/>
+              </a:rPr>
+              <a:t>–  AuthService injiziert HouseholdService, eine @Transactional-Einheit</a:t>
             </a:r>
           </a:p>
           <a:p>
             <a:pPr>
               <a:spcAft>
-                <a:spcPts val="600"/>
+                <a:spcPts val="700"/>
               </a:spcAft>
             </a:pPr>
             <a:r>
-              <a:rPr sz="2000" b="1">
-                <a:solidFill>
-                  <a:srgbClr val="1F2D3D"/>
-                </a:solidFill>
-              </a:rPr>
-              <a:t>#4 Rezept-Rating (1-5 Sterne)</a:t>
-            </a:r>
-          </a:p>
-          <a:p>
-            <a:pPr lvl="1">
+              <a:rPr sz="1800" b="1">
+                <a:solidFill>
+                  <a:srgbClr val="1A1A1A"/>
+                </a:solidFill>
+                <a:latin typeface="Arial"/>
+              </a:rPr>
+              <a:t>▪  #4 Rezept-Rating (1-5 Sterne) — einziger Schema-Eingriff (V8)</a:t>
+            </a:r>
+          </a:p>
+          <a:p>
+            <a:pPr>
               <a:spcAft>
-                <a:spcPts val="600"/>
+                <a:spcPts val="700"/>
               </a:spcAft>
             </a:pPr>
             <a:r>
-              <a:rPr sz="1800" b="0">
-                <a:solidFill>
-                  <a:srgbClr val="555555"/>
-                </a:solidFill>
-              </a:rPr>
-              <a:t>–  Neuer Slice: Migration V8, Entity, Service, REST, UI — einziger Schema-Eingriff</a:t>
+              <a:rPr sz="1800" b="1">
+                <a:solidFill>
+                  <a:srgbClr val="1A1A1A"/>
+                </a:solidFill>
+                <a:latin typeface="Arial"/>
+              </a:rPr>
+              <a:t>▪  #5 Einkaufsliste explizit gegen Vorrat pruefen vor Ausstellen</a:t>
             </a:r>
           </a:p>
           <a:p>
             <a:pPr>
               <a:spcAft>
-                <a:spcPts val="600"/>
+                <a:spcPts val="700"/>
               </a:spcAft>
             </a:pPr>
             <a:r>
-              <a:rPr sz="2000" b="1">
-                <a:solidFill>
-                  <a:srgbClr val="1F2D3D"/>
-                </a:solidFill>
-              </a:rPr>
-              <a:t>#5 Einkaufsliste explizit gegen Vorrat pruefen vor Ausstellen</a:t>
+              <a:rPr sz="1800" b="1">
+                <a:solidFill>
+                  <a:srgbClr val="1A1A1A"/>
+                </a:solidFill>
+                <a:latin typeface="Arial"/>
+              </a:rPr>
+              <a:t>▪  #6 LLM-Modell verifizieren / leichteres Modell</a:t>
             </a:r>
           </a:p>
           <a:p>
             <a:pPr>
               <a:spcAft>
-                <a:spcPts val="600"/>
+                <a:spcPts val="700"/>
               </a:spcAft>
             </a:pPr>
             <a:r>
-              <a:rPr sz="2000" b="1">
-                <a:solidFill>
-                  <a:srgbClr val="1F2D3D"/>
-                </a:solidFill>
-              </a:rPr>
-              <a:t>#6 LLM-Modell verifizieren / leichteres Modell fuer Rechenkapazitaet</a:t>
+              <a:rPr sz="1800" b="1">
+                <a:solidFill>
+                  <a:srgbClr val="1A1A1A"/>
+                </a:solidFill>
+                <a:latin typeface="Arial"/>
+              </a:rPr>
+              <a:t>▪  #7 Vercel-Deployment fuers Frontend</a:t>
             </a:r>
           </a:p>
           <a:p>
             <a:pPr>
               <a:spcAft>
-                <a:spcPts val="600"/>
+                <a:spcPts val="700"/>
               </a:spcAft>
             </a:pPr>
             <a:r>
-              <a:rPr sz="2000" b="1">
-                <a:solidFill>
-                  <a:srgbClr val="1F2D3D"/>
-                </a:solidFill>
-              </a:rPr>
-              <a:t>#7 Vercel-Deployment fuers Frontend</a:t>
-            </a:r>
-          </a:p>
-          <a:p>
-            <a:pPr>
-              <a:spcAft>
-                <a:spcPts val="600"/>
-              </a:spcAft>
-            </a:pPr>
-            <a:r>
-              <a:rPr sz="2000" b="1">
-                <a:solidFill>
-                  <a:srgbClr val="1F2D3D"/>
-                </a:solidFill>
-              </a:rPr>
-              <a:t>#8 Backup-Plan, Abhaengigkeiten &amp; Scope dokumentieren</a:t>
+              <a:rPr sz="1800" b="1">
+                <a:solidFill>
+                  <a:srgbClr val="1A1A1A"/>
+                </a:solidFill>
+                <a:latin typeface="Arial"/>
+              </a:rPr>
+              <a:t>▪  #8 Backup-Plan, Abhaengigkeiten &amp; Scope dokumentieren</a:t>
+            </a:r>
+          </a:p>
+        </p:txBody>
+      </p:sp>
+      <p:sp>
+        <p:nvSpPr>
+          <p:cNvPr id="5" name="TextBox 4"/>
+          <p:cNvSpPr txBox="1"/>
+          <p:nvPr/>
+        </p:nvSpPr>
+        <p:spPr>
+          <a:xfrm>
+            <a:off x="640080" y="6400800"/>
+            <a:ext cx="5486400" cy="365760"/>
+          </a:xfrm>
+          <a:prstGeom prst="rect">
+            <a:avLst/>
+          </a:prstGeom>
+          <a:noFill/>
+        </p:spPr>
+        <p:txBody>
+          <a:bodyPr wrap="none">
+            <a:spAutoFit/>
+          </a:bodyPr>
+          <a:lstStyle/>
+          <a:p>
+            <a:r>
+              <a:rPr sz="900">
+                <a:solidFill>
+                  <a:srgbClr val="777777"/>
+                </a:solidFill>
+                <a:latin typeface="Arial"/>
+              </a:rPr>
+              <a:t>EatEasy EE — Architektur</a:t>
+            </a:r>
+          </a:p>
+        </p:txBody>
+      </p:sp>
+      <p:sp>
+        <p:nvSpPr>
+          <p:cNvPr id="6" name="TextBox 5"/>
+          <p:cNvSpPr txBox="1"/>
+          <p:nvPr/>
+        </p:nvSpPr>
+        <p:spPr>
+          <a:xfrm>
+            <a:off x="6400800" y="6400800"/>
+            <a:ext cx="5120640" cy="365760"/>
+          </a:xfrm>
+          <a:prstGeom prst="rect">
+            <a:avLst/>
+          </a:prstGeom>
+          <a:noFill/>
+        </p:spPr>
+        <p:txBody>
+          <a:bodyPr wrap="none">
+            <a:spAutoFit/>
+          </a:bodyPr>
+          <a:lstStyle/>
+          <a:p>
+            <a:pPr algn="r"/>
+            <a:r>
+              <a:rPr sz="900">
+                <a:solidFill>
+                  <a:srgbClr val="777777"/>
+                </a:solidFill>
+                <a:latin typeface="Arial"/>
+              </a:rPr>
+              <a:t>Folie 6 / 7</a:t>
             </a:r>
           </a:p>
         </p:txBody>
@@ -4296,8 +4950,8 @@
         </p:nvSpPr>
         <p:spPr>
           <a:xfrm>
-            <a:off x="548640" y="320040"/>
-            <a:ext cx="11064240" cy="822960"/>
+            <a:off x="640080" y="365760"/>
+            <a:ext cx="10972800" cy="822960"/>
           </a:xfrm>
           <a:prstGeom prst="rect">
             <a:avLst/>
@@ -4311,10 +4965,20 @@
           <a:lstStyle/>
           <a:p>
             <a:r>
-              <a:rPr sz="3000" b="1">
-                <a:solidFill>
-                  <a:srgbClr val="1F2D3D"/>
-                </a:solidFill>
+              <a:rPr sz="2800" b="1">
+                <a:solidFill>
+                  <a:srgbClr val="2D5A47"/>
+                </a:solidFill>
+                <a:latin typeface="Arial"/>
+              </a:rPr>
+              <a:t>6  </a:t>
+            </a:r>
+            <a:r>
+              <a:rPr sz="2800" b="1">
+                <a:solidFill>
+                  <a:srgbClr val="1A1A1A"/>
+                </a:solidFill>
+                <a:latin typeface="Arial"/>
               </a:rPr>
               <a:t>Kernaussage</a:t>
             </a:r>
@@ -4329,14 +4993,14 @@
         </p:nvSpPr>
         <p:spPr>
           <a:xfrm>
-            <a:off x="594360" y="1143000"/>
-            <a:ext cx="2377440" cy="38100"/>
+            <a:off x="658368" y="1170432"/>
+            <a:ext cx="10893247" cy="25400"/>
           </a:xfrm>
           <a:prstGeom prst="rect">
             <a:avLst/>
           </a:prstGeom>
           <a:solidFill>
-            <a:srgbClr val="2E7D32"/>
+            <a:srgbClr val="2D5A47"/>
           </a:solidFill>
           <a:ln>
             <a:noFill/>
@@ -4372,8 +5036,8 @@
         </p:nvSpPr>
         <p:spPr>
           <a:xfrm>
-            <a:off x="640080" y="1371600"/>
-            <a:ext cx="10972800" cy="5029200"/>
+            <a:off x="685800" y="1417320"/>
+            <a:ext cx="10972800" cy="4754880"/>
           </a:xfrm>
           <a:prstGeom prst="rect">
             <a:avLst/>
@@ -4388,29 +5052,31 @@
           <a:p>
             <a:pPr>
               <a:spcAft>
-                <a:spcPts val="600"/>
+                <a:spcPts val="700"/>
               </a:spcAft>
             </a:pPr>
             <a:r>
-              <a:rPr sz="2000" b="1">
-                <a:solidFill>
-                  <a:srgbClr val="1F2D3D"/>
-                </a:solidFill>
-              </a:rPr>
-              <a:t>Architektur bleibt unveraendert stabil:</a:t>
+              <a:rPr sz="1800" b="1">
+                <a:solidFill>
+                  <a:srgbClr val="1A1A1A"/>
+                </a:solidFill>
+                <a:latin typeface="Arial"/>
+              </a:rPr>
+              <a:t>▪  Architektur bleibt unveraendert stabil:</a:t>
             </a:r>
           </a:p>
           <a:p>
             <a:pPr lvl="1">
               <a:spcAft>
-                <a:spcPts val="600"/>
+                <a:spcPts val="700"/>
               </a:spcAft>
             </a:pPr>
             <a:r>
-              <a:rPr sz="1800" b="0">
-                <a:solidFill>
-                  <a:srgbClr val="555555"/>
-                </a:solidFill>
+              <a:rPr sz="1600" b="0">
+                <a:solidFill>
+                  <a:srgbClr val="333333"/>
+                </a:solidFill>
+                <a:latin typeface="Arial"/>
               </a:rPr>
               <a:t>–  Modularer Monolith, Service-Interfaces, strikte DTO-Trennung</a:t>
             </a:r>
@@ -4418,14 +5084,15 @@
           <a:p>
             <a:pPr lvl="1">
               <a:spcAft>
-                <a:spcPts val="600"/>
+                <a:spcPts val="700"/>
               </a:spcAft>
             </a:pPr>
             <a:r>
-              <a:rPr sz="1800" b="0">
-                <a:solidFill>
-                  <a:srgbClr val="555555"/>
-                </a:solidFill>
+              <a:rPr sz="1600" b="0">
+                <a:solidFill>
+                  <a:srgbClr val="333333"/>
+                </a:solidFill>
+                <a:latin typeface="Arial"/>
               </a:rPr>
               <a:t>–  JWT + Service-Layer-Authz, Flyway, UUID</a:t>
             </a:r>
@@ -4433,31 +5100,102 @@
           <a:p>
             <a:pPr>
               <a:spcAft>
-                <a:spcPts val="600"/>
+                <a:spcPts val="700"/>
               </a:spcAft>
             </a:pPr>
             <a:r>
-              <a:rPr sz="2000" b="1">
-                <a:solidFill>
-                  <a:srgbClr val="1F2D3D"/>
-                </a:solidFill>
-              </a:rPr>
-              <a:t>Von den geplanten Aenderungen beruehrt nur #4 (Rating) das Datenmodell</a:t>
+              <a:rPr sz="1800" b="1">
+                <a:solidFill>
+                  <a:srgbClr val="1A1A1A"/>
+                </a:solidFill>
+                <a:latin typeface="Arial"/>
+              </a:rPr>
+              <a:t>▪  Nur #4 (Rating) beruehrt das Datenmodell</a:t>
             </a:r>
           </a:p>
           <a:p>
             <a:pPr>
               <a:spcAft>
-                <a:spcPts val="600"/>
+                <a:spcPts val="700"/>
               </a:spcAft>
             </a:pPr>
             <a:r>
-              <a:rPr sz="2000" b="1">
-                <a:solidFill>
-                  <a:srgbClr val="1F2D3D"/>
-                </a:solidFill>
-              </a:rPr>
-              <a:t>Alles andere ist Service-Logik, Config oder Deployment/Doku</a:t>
+              <a:rPr sz="1800" b="1">
+                <a:solidFill>
+                  <a:srgbClr val="1A1A1A"/>
+                </a:solidFill>
+                <a:latin typeface="Arial"/>
+              </a:rPr>
+              <a:t>▪  Alles andere ist Service-Logik, Config oder Deployment/Doku</a:t>
+            </a:r>
+          </a:p>
+        </p:txBody>
+      </p:sp>
+      <p:sp>
+        <p:nvSpPr>
+          <p:cNvPr id="5" name="TextBox 4"/>
+          <p:cNvSpPr txBox="1"/>
+          <p:nvPr/>
+        </p:nvSpPr>
+        <p:spPr>
+          <a:xfrm>
+            <a:off x="640080" y="6400800"/>
+            <a:ext cx="5486400" cy="365760"/>
+          </a:xfrm>
+          <a:prstGeom prst="rect">
+            <a:avLst/>
+          </a:prstGeom>
+          <a:noFill/>
+        </p:spPr>
+        <p:txBody>
+          <a:bodyPr wrap="none">
+            <a:spAutoFit/>
+          </a:bodyPr>
+          <a:lstStyle/>
+          <a:p>
+            <a:r>
+              <a:rPr sz="900">
+                <a:solidFill>
+                  <a:srgbClr val="777777"/>
+                </a:solidFill>
+                <a:latin typeface="Arial"/>
+              </a:rPr>
+              <a:t>EatEasy EE — Architektur</a:t>
+            </a:r>
+          </a:p>
+        </p:txBody>
+      </p:sp>
+      <p:sp>
+        <p:nvSpPr>
+          <p:cNvPr id="6" name="TextBox 5"/>
+          <p:cNvSpPr txBox="1"/>
+          <p:nvPr/>
+        </p:nvSpPr>
+        <p:spPr>
+          <a:xfrm>
+            <a:off x="6400800" y="6400800"/>
+            <a:ext cx="5120640" cy="365760"/>
+          </a:xfrm>
+          <a:prstGeom prst="rect">
+            <a:avLst/>
+          </a:prstGeom>
+          <a:noFill/>
+        </p:spPr>
+        <p:txBody>
+          <a:bodyPr wrap="none">
+            <a:spAutoFit/>
+          </a:bodyPr>
+          <a:lstStyle/>
+          <a:p>
+            <a:pPr algn="r"/>
+            <a:r>
+              <a:rPr sz="900">
+                <a:solidFill>
+                  <a:srgbClr val="777777"/>
+                </a:solidFill>
+                <a:latin typeface="Arial"/>
+              </a:rPr>
+              <a:t>Folie 7 / 7</a:t>
             </a:r>
           </a:p>
         </p:txBody>

</xml_diff>

<commit_message>
style: Architektur-Deck grafisch aufbereiten (Struktur, Datenmodell, Technologien)
Textarme, grafische Folien im EatEasy-Hausstil: Architektur-Diagramm
(Frontend -> REST -> Backend-Komponenten -> DB + externe Systeme),
ER-Datenmodell in vier Domaenen-Clustern und Technologie-Chips nach Layer.
PPTX wird aus den gerenderten PDF-Folien gebaut (pixelgleich).

Co-Authored-By: Claude Opus 4.8 (1M context) <noreply@anthropic.com>
Claude-Session: https://claude.ai/code/session_01UMhECF8MTyHP6rFM1ZeaDP
</commit_message>
<xml_diff>
--- a/EatEasy-Architektur.pptx
+++ b/EatEasy-Architektur.pptx
@@ -9,9 +9,6 @@
     <p:sldId id="257" r:id="rId8"/>
     <p:sldId id="258" r:id="rId9"/>
     <p:sldId id="259" r:id="rId10"/>
-    <p:sldId id="260" r:id="rId11"/>
-    <p:sldId id="261" r:id="rId12"/>
-    <p:sldId id="262" r:id="rId13"/>
   </p:sldIdLst>
   <p:sldSz cx="12191695" cy="6858000" type="screen4x3"/>
   <p:notesSz cx="6858000" cy="9144000"/>
@@ -3087,14 +3084,6 @@
 <file path=ppt/slides/slide1.xml><?xml version="1.0" encoding="utf-8"?>
 <p:sld xmlns:a="http://schemas.openxmlformats.org/drawingml/2006/main" xmlns:p="http://schemas.openxmlformats.org/presentationml/2006/main" xmlns:r="http://schemas.openxmlformats.org/officeDocument/2006/relationships">
   <p:cSld>
-    <p:bg>
-      <p:bgPr>
-        <a:solidFill>
-          <a:srgbClr val="1E3A2F"/>
-        </a:solidFill>
-        <a:effectLst/>
-      </p:bgPr>
-    </p:bg>
     <p:spTree>
       <p:nvGrpSpPr>
         <p:cNvPr id="1" name=""/>
@@ -3102,288 +3091,30 @@
         <p:nvPr/>
       </p:nvGrpSpPr>
       <p:grpSpPr/>
-      <p:sp>
-        <p:nvSpPr>
-          <p:cNvPr id="2" name="Rectangle 1"/>
-          <p:cNvSpPr/>
+      <p:pic>
+        <p:nvPicPr>
+          <p:cNvPr id="2" name="Picture 1" descr="slide_1.png"/>
+          <p:cNvPicPr>
+            <a:picLocks noChangeAspect="1"/>
+          </p:cNvPicPr>
           <p:nvPr/>
-        </p:nvSpPr>
+        </p:nvPicPr>
+        <p:blipFill>
+          <a:blip r:embed="rId2"/>
+          <a:stretch>
+            <a:fillRect/>
+          </a:stretch>
+        </p:blipFill>
         <p:spPr>
           <a:xfrm>
             <a:off x="0" y="0"/>
-            <a:ext cx="12191695" cy="292608"/>
+            <a:ext cx="12191695" cy="6858000"/>
           </a:xfrm>
           <a:prstGeom prst="rect">
             <a:avLst/>
           </a:prstGeom>
-          <a:solidFill>
-            <a:srgbClr val="2D5A47"/>
-          </a:solidFill>
-          <a:ln>
-            <a:noFill/>
-          </a:ln>
         </p:spPr>
-        <p:style>
-          <a:lnRef idx="1">
-            <a:schemeClr val="accent1"/>
-          </a:lnRef>
-          <a:fillRef idx="3">
-            <a:schemeClr val="accent1"/>
-          </a:fillRef>
-          <a:effectRef idx="2">
-            <a:schemeClr val="accent1"/>
-          </a:effectRef>
-          <a:fontRef idx="minor">
-            <a:schemeClr val="lt1"/>
-          </a:fontRef>
-        </p:style>
-        <p:txBody>
-          <a:bodyPr rtlCol="0" anchor="ctr"/>
-          <a:lstStyle/>
-          <a:p>
-            <a:pPr algn="ctr"/>
-          </a:p>
-        </p:txBody>
-      </p:sp>
-      <p:sp>
-        <p:nvSpPr>
-          <p:cNvPr id="3" name="TextBox 2"/>
-          <p:cNvSpPr txBox="1"/>
-          <p:nvPr/>
-        </p:nvSpPr>
-        <p:spPr>
-          <a:xfrm>
-            <a:off x="822960" y="1920240"/>
-            <a:ext cx="10515600" cy="457200"/>
-          </a:xfrm>
-          <a:prstGeom prst="rect">
-            <a:avLst/>
-          </a:prstGeom>
-          <a:noFill/>
-        </p:spPr>
-        <p:txBody>
-          <a:bodyPr wrap="none">
-            <a:spAutoFit/>
-          </a:bodyPr>
-          <a:lstStyle/>
-          <a:p>
-            <a:r>
-              <a:rPr sz="1300">
-                <a:solidFill>
-                  <a:srgbClr val="9FB6A9"/>
-                </a:solidFill>
-                <a:latin typeface="Arial"/>
-              </a:rPr>
-              <a:t>K O M P O N E N T E N B A S I E R T E   S O F T W A R E E N T W I C K L U N G</a:t>
-            </a:r>
-          </a:p>
-        </p:txBody>
-      </p:sp>
-      <p:sp>
-        <p:nvSpPr>
-          <p:cNvPr id="4" name="TextBox 3"/>
-          <p:cNvSpPr txBox="1"/>
-          <p:nvPr/>
-        </p:nvSpPr>
-        <p:spPr>
-          <a:xfrm>
-            <a:off x="777240" y="2377440"/>
-            <a:ext cx="10607040" cy="1188720"/>
-          </a:xfrm>
-          <a:prstGeom prst="rect">
-            <a:avLst/>
-          </a:prstGeom>
-          <a:noFill/>
-        </p:spPr>
-        <p:txBody>
-          <a:bodyPr wrap="none">
-            <a:spAutoFit/>
-          </a:bodyPr>
-          <a:lstStyle/>
-          <a:p>
-            <a:r>
-              <a:rPr sz="5000" b="1">
-                <a:solidFill>
-                  <a:srgbClr val="FFFFFF"/>
-                </a:solidFill>
-                <a:latin typeface="Arial"/>
-              </a:rPr>
-              <a:t>EatEasy EE — Architektur</a:t>
-            </a:r>
-          </a:p>
-        </p:txBody>
-      </p:sp>
-      <p:sp>
-        <p:nvSpPr>
-          <p:cNvPr id="5" name="TextBox 4"/>
-          <p:cNvSpPr txBox="1"/>
-          <p:nvPr/>
-        </p:nvSpPr>
-        <p:spPr>
-          <a:xfrm>
-            <a:off x="822960" y="3566160"/>
-            <a:ext cx="10515600" cy="1097280"/>
-          </a:xfrm>
-          <a:prstGeom prst="rect">
-            <a:avLst/>
-          </a:prstGeom>
-          <a:noFill/>
-        </p:spPr>
-        <p:txBody>
-          <a:bodyPr wrap="square">
-            <a:spAutoFit/>
-          </a:bodyPr>
-          <a:lstStyle/>
-          <a:p>
-            <a:r>
-              <a:rPr sz="2000">
-                <a:solidFill>
-                  <a:srgbClr val="C9D8CF"/>
-                </a:solidFill>
-                <a:latin typeface="Arial"/>
-              </a:rPr>
-              <a:t>Modularer Monolith · Vue 3 + Quarkus</a:t>
-            </a:r>
-          </a:p>
-          <a:p>
-            <a:r>
-              <a:rPr sz="2000">
-                <a:solidFill>
-                  <a:srgbClr val="C9D8CF"/>
-                </a:solidFill>
-                <a:latin typeface="Arial"/>
-              </a:rPr>
-              <a:t>Studienprojekt Gruppe 5</a:t>
-            </a:r>
-          </a:p>
-        </p:txBody>
-      </p:sp>
-      <p:sp>
-        <p:nvSpPr>
-          <p:cNvPr id="6" name="Rectangle 5"/>
-          <p:cNvSpPr/>
-          <p:nvPr/>
-        </p:nvSpPr>
-        <p:spPr>
-          <a:xfrm>
-            <a:off x="822960" y="5440680"/>
-            <a:ext cx="10545775" cy="12700"/>
-          </a:xfrm>
-          <a:prstGeom prst="rect">
-            <a:avLst/>
-          </a:prstGeom>
-          <a:solidFill>
-            <a:srgbClr val="2D5A47"/>
-          </a:solidFill>
-          <a:ln>
-            <a:noFill/>
-          </a:ln>
-        </p:spPr>
-        <p:style>
-          <a:lnRef idx="1">
-            <a:schemeClr val="accent1"/>
-          </a:lnRef>
-          <a:fillRef idx="3">
-            <a:schemeClr val="accent1"/>
-          </a:fillRef>
-          <a:effectRef idx="2">
-            <a:schemeClr val="accent1"/>
-          </a:effectRef>
-          <a:fontRef idx="minor">
-            <a:schemeClr val="lt1"/>
-          </a:fontRef>
-        </p:style>
-        <p:txBody>
-          <a:bodyPr rtlCol="0" anchor="ctr"/>
-          <a:lstStyle/>
-          <a:p>
-            <a:pPr algn="ctr"/>
-          </a:p>
-        </p:txBody>
-      </p:sp>
-      <p:sp>
-        <p:nvSpPr>
-          <p:cNvPr id="7" name="TextBox 6"/>
-          <p:cNvSpPr txBox="1"/>
-          <p:nvPr/>
-        </p:nvSpPr>
-        <p:spPr>
-          <a:xfrm>
-            <a:off x="822960" y="5623560"/>
-            <a:ext cx="10515600" cy="1097280"/>
-          </a:xfrm>
-          <a:prstGeom prst="rect">
-            <a:avLst/>
-          </a:prstGeom>
-          <a:noFill/>
-        </p:spPr>
-        <p:txBody>
-          <a:bodyPr wrap="square">
-            <a:spAutoFit/>
-          </a:bodyPr>
-          <a:lstStyle/>
-          <a:p>
-            <a:r>
-              <a:rPr sz="1200">
-                <a:solidFill>
-                  <a:srgbClr val="9FB6A9"/>
-                </a:solidFill>
-                <a:latin typeface="Arial"/>
-              </a:rPr>
-              <a:t>Thema         </a:t>
-            </a:r>
-            <a:r>
-              <a:rPr sz="1200">
-                <a:solidFill>
-                  <a:srgbClr val="FFFFFF"/>
-                </a:solidFill>
-                <a:latin typeface="Arial"/>
-              </a:rPr>
-              <a:t>    Architekturüberblick &amp; Planung</a:t>
-            </a:r>
-          </a:p>
-          <a:p>
-            <a:r>
-              <a:rPr sz="1200">
-                <a:solidFill>
-                  <a:srgbClr val="9FB6A9"/>
-                </a:solidFill>
-                <a:latin typeface="Arial"/>
-              </a:rPr>
-              <a:t>Stack         </a:t>
-            </a:r>
-            <a:r>
-              <a:rPr sz="1200">
-                <a:solidFill>
-                  <a:srgbClr val="FFFFFF"/>
-                </a:solidFill>
-                <a:latin typeface="Arial"/>
-              </a:rPr>
-              <a:t>    Vue.js · Quarkus · PostgreSQL · Docker</a:t>
-            </a:r>
-          </a:p>
-          <a:p>
-            <a:r>
-              <a:rPr sz="1200">
-                <a:solidFill>
-                  <a:srgbClr val="9FB6A9"/>
-                </a:solidFill>
-                <a:latin typeface="Arial"/>
-              </a:rPr>
-              <a:t>Stand         </a:t>
-            </a:r>
-            <a:r>
-              <a:rPr sz="1200">
-                <a:solidFill>
-                  <a:srgbClr val="FFFFFF"/>
-                </a:solidFill>
-                <a:latin typeface="Arial"/>
-              </a:rPr>
-              <a:t>    Phasen 0–10 umgesetzt, Issues #3–#8 offen</a:t>
-            </a:r>
-          </a:p>
-        </p:txBody>
-      </p:sp>
+      </p:pic>
     </p:spTree>
   </p:cSld>
   <p:clrMapOvr>
@@ -3402,312 +3133,30 @@
         <p:nvPr/>
       </p:nvGrpSpPr>
       <p:grpSpPr/>
-      <p:sp>
-        <p:nvSpPr>
-          <p:cNvPr id="2" name="TextBox 1"/>
-          <p:cNvSpPr txBox="1"/>
+      <p:pic>
+        <p:nvPicPr>
+          <p:cNvPr id="2" name="Picture 1" descr="slide_2.png"/>
+          <p:cNvPicPr>
+            <a:picLocks noChangeAspect="1"/>
+          </p:cNvPicPr>
           <p:nvPr/>
-        </p:nvSpPr>
+        </p:nvPicPr>
+        <p:blipFill>
+          <a:blip r:embed="rId2"/>
+          <a:stretch>
+            <a:fillRect/>
+          </a:stretch>
+        </p:blipFill>
         <p:spPr>
           <a:xfrm>
-            <a:off x="640080" y="365760"/>
-            <a:ext cx="10972800" cy="822960"/>
+            <a:off x="0" y="0"/>
+            <a:ext cx="12191695" cy="6858000"/>
           </a:xfrm>
           <a:prstGeom prst="rect">
             <a:avLst/>
           </a:prstGeom>
-          <a:noFill/>
         </p:spPr>
-        <p:txBody>
-          <a:bodyPr wrap="none">
-            <a:spAutoFit/>
-          </a:bodyPr>
-          <a:lstStyle/>
-          <a:p>
-            <a:r>
-              <a:rPr sz="2800" b="1">
-                <a:solidFill>
-                  <a:srgbClr val="2D5A47"/>
-                </a:solidFill>
-                <a:latin typeface="Arial"/>
-              </a:rPr>
-              <a:t>1  </a:t>
-            </a:r>
-            <a:r>
-              <a:rPr sz="2800" b="1">
-                <a:solidFill>
-                  <a:srgbClr val="1A1A1A"/>
-                </a:solidFill>
-                <a:latin typeface="Arial"/>
-              </a:rPr>
-              <a:t>Grundsatzentscheidungen</a:t>
-            </a:r>
-          </a:p>
-        </p:txBody>
-      </p:sp>
-      <p:sp>
-        <p:nvSpPr>
-          <p:cNvPr id="3" name="Rectangle 2"/>
-          <p:cNvSpPr/>
-          <p:nvPr/>
-        </p:nvSpPr>
-        <p:spPr>
-          <a:xfrm>
-            <a:off x="658368" y="1170432"/>
-            <a:ext cx="10893247" cy="25400"/>
-          </a:xfrm>
-          <a:prstGeom prst="rect">
-            <a:avLst/>
-          </a:prstGeom>
-          <a:solidFill>
-            <a:srgbClr val="2D5A47"/>
-          </a:solidFill>
-          <a:ln>
-            <a:noFill/>
-          </a:ln>
-        </p:spPr>
-        <p:style>
-          <a:lnRef idx="1">
-            <a:schemeClr val="accent1"/>
-          </a:lnRef>
-          <a:fillRef idx="3">
-            <a:schemeClr val="accent1"/>
-          </a:fillRef>
-          <a:effectRef idx="2">
-            <a:schemeClr val="accent1"/>
-          </a:effectRef>
-          <a:fontRef idx="minor">
-            <a:schemeClr val="lt1"/>
-          </a:fontRef>
-        </p:style>
-        <p:txBody>
-          <a:bodyPr rtlCol="0" anchor="ctr"/>
-          <a:lstStyle/>
-          <a:p>
-            <a:pPr algn="ctr"/>
-          </a:p>
-        </p:txBody>
-      </p:sp>
-      <p:sp>
-        <p:nvSpPr>
-          <p:cNvPr id="4" name="TextBox 3"/>
-          <p:cNvSpPr txBox="1"/>
-          <p:nvPr/>
-        </p:nvSpPr>
-        <p:spPr>
-          <a:xfrm>
-            <a:off x="685800" y="1417320"/>
-            <a:ext cx="10972800" cy="4754880"/>
-          </a:xfrm>
-          <a:prstGeom prst="rect">
-            <a:avLst/>
-          </a:prstGeom>
-          <a:noFill/>
-        </p:spPr>
-        <p:txBody>
-          <a:bodyPr wrap="square">
-            <a:spAutoFit/>
-          </a:bodyPr>
-          <a:lstStyle/>
-          <a:p>
-            <a:pPr>
-              <a:spcAft>
-                <a:spcPts val="700"/>
-              </a:spcAft>
-            </a:pPr>
-            <a:r>
-              <a:rPr sz="1800" b="1">
-                <a:solidFill>
-                  <a:srgbClr val="1A1A1A"/>
-                </a:solidFill>
-                <a:latin typeface="Arial"/>
-              </a:rPr>
-              <a:t>▪  Architekturstil: Modularer Monolith</a:t>
-            </a:r>
-          </a:p>
-          <a:p>
-            <a:pPr lvl="1">
-              <a:spcAft>
-                <a:spcPts val="700"/>
-              </a:spcAft>
-            </a:pPr>
-            <a:r>
-              <a:rPr sz="1600" b="0">
-                <a:solidFill>
-                  <a:srgbClr val="333333"/>
-                </a:solidFill>
-                <a:latin typeface="Arial"/>
-              </a:rPr>
-              <a:t>–  Fachliche Komponenten statt technischer Layer</a:t>
-            </a:r>
-          </a:p>
-          <a:p>
-            <a:pPr lvl="1">
-              <a:spcAft>
-                <a:spcPts val="700"/>
-              </a:spcAft>
-            </a:pPr>
-            <a:r>
-              <a:rPr sz="1600" b="0">
-                <a:solidFill>
-                  <a:srgbClr val="333333"/>
-                </a:solidFill>
-                <a:latin typeface="Arial"/>
-              </a:rPr>
-              <a:t>–  Kommunikation nur ueber Service-Interfaces (CDI), nie via REST</a:t>
-            </a:r>
-          </a:p>
-          <a:p>
-            <a:pPr>
-              <a:spcAft>
-                <a:spcPts val="700"/>
-              </a:spcAft>
-            </a:pPr>
-            <a:r>
-              <a:rPr sz="1800" b="1">
-                <a:solidFill>
-                  <a:srgbClr val="1A1A1A"/>
-                </a:solidFill>
-                <a:latin typeface="Arial"/>
-              </a:rPr>
-              <a:t>▪  Strikte DTO-Trennung</a:t>
-            </a:r>
-          </a:p>
-          <a:p>
-            <a:pPr lvl="1">
-              <a:spcAft>
-                <a:spcPts val="700"/>
-              </a:spcAft>
-            </a:pPr>
-            <a:r>
-              <a:rPr sz="1600" b="0">
-                <a:solidFill>
-                  <a:srgbClr val="333333"/>
-                </a:solidFill>
-                <a:latin typeface="Arial"/>
-              </a:rPr>
-              <a:t>–  Entities lecken nie aus REST-Endpunkten; DTOs sind Java-Records</a:t>
-            </a:r>
-          </a:p>
-          <a:p>
-            <a:pPr>
-              <a:spcAft>
-                <a:spcPts val="700"/>
-              </a:spcAft>
-            </a:pPr>
-            <a:r>
-              <a:rPr sz="1800" b="1">
-                <a:solidFill>
-                  <a:srgbClr val="1A1A1A"/>
-                </a:solidFill>
-                <a:latin typeface="Arial"/>
-              </a:rPr>
-              <a:t>▪  Auth: Stateless JWT (8 h)</a:t>
-            </a:r>
-          </a:p>
-          <a:p>
-            <a:pPr lvl="1">
-              <a:spcAft>
-                <a:spcPts val="700"/>
-              </a:spcAft>
-            </a:pPr>
-            <a:r>
-              <a:rPr sz="1600" b="0">
-                <a:solidFill>
-                  <a:srgbClr val="333333"/>
-                </a:solidFill>
-                <a:latin typeface="Arial"/>
-              </a:rPr>
-              <a:t>–  @RolesAllowed plus Authorization-Checks im Service-Layer</a:t>
-            </a:r>
-          </a:p>
-          <a:p>
-            <a:pPr>
-              <a:spcAft>
-                <a:spcPts val="700"/>
-              </a:spcAft>
-            </a:pPr>
-            <a:r>
-              <a:rPr sz="1800" b="1">
-                <a:solidFill>
-                  <a:srgbClr val="1A1A1A"/>
-                </a:solidFill>
-                <a:latin typeface="Arial"/>
-              </a:rPr>
-              <a:t>▪  Daten: UUID v4, Flyway-Migrationen, Hibernate = validate</a:t>
-            </a:r>
-          </a:p>
-        </p:txBody>
-      </p:sp>
-      <p:sp>
-        <p:nvSpPr>
-          <p:cNvPr id="5" name="TextBox 4"/>
-          <p:cNvSpPr txBox="1"/>
-          <p:nvPr/>
-        </p:nvSpPr>
-        <p:spPr>
-          <a:xfrm>
-            <a:off x="640080" y="6400800"/>
-            <a:ext cx="5486400" cy="365760"/>
-          </a:xfrm>
-          <a:prstGeom prst="rect">
-            <a:avLst/>
-          </a:prstGeom>
-          <a:noFill/>
-        </p:spPr>
-        <p:txBody>
-          <a:bodyPr wrap="none">
-            <a:spAutoFit/>
-          </a:bodyPr>
-          <a:lstStyle/>
-          <a:p>
-            <a:r>
-              <a:rPr sz="900">
-                <a:solidFill>
-                  <a:srgbClr val="777777"/>
-                </a:solidFill>
-                <a:latin typeface="Arial"/>
-              </a:rPr>
-              <a:t>EatEasy EE — Architektur</a:t>
-            </a:r>
-          </a:p>
-        </p:txBody>
-      </p:sp>
-      <p:sp>
-        <p:nvSpPr>
-          <p:cNvPr id="6" name="TextBox 5"/>
-          <p:cNvSpPr txBox="1"/>
-          <p:nvPr/>
-        </p:nvSpPr>
-        <p:spPr>
-          <a:xfrm>
-            <a:off x="6400800" y="6400800"/>
-            <a:ext cx="5120640" cy="365760"/>
-          </a:xfrm>
-          <a:prstGeom prst="rect">
-            <a:avLst/>
-          </a:prstGeom>
-          <a:noFill/>
-        </p:spPr>
-        <p:txBody>
-          <a:bodyPr wrap="none">
-            <a:spAutoFit/>
-          </a:bodyPr>
-          <a:lstStyle/>
-          <a:p>
-            <a:pPr algn="r"/>
-            <a:r>
-              <a:rPr sz="900">
-                <a:solidFill>
-                  <a:srgbClr val="777777"/>
-                </a:solidFill>
-                <a:latin typeface="Arial"/>
-              </a:rPr>
-              <a:t>Folie 2 / 7</a:t>
-            </a:r>
-          </a:p>
-        </p:txBody>
-      </p:sp>
+      </p:pic>
     </p:spTree>
   </p:cSld>
   <p:clrMapOvr>
@@ -3726,312 +3175,30 @@
         <p:nvPr/>
       </p:nvGrpSpPr>
       <p:grpSpPr/>
-      <p:sp>
-        <p:nvSpPr>
-          <p:cNvPr id="2" name="TextBox 1"/>
-          <p:cNvSpPr txBox="1"/>
+      <p:pic>
+        <p:nvPicPr>
+          <p:cNvPr id="2" name="Picture 1" descr="slide_3.png"/>
+          <p:cNvPicPr>
+            <a:picLocks noChangeAspect="1"/>
+          </p:cNvPicPr>
           <p:nvPr/>
-        </p:nvSpPr>
+        </p:nvPicPr>
+        <p:blipFill>
+          <a:blip r:embed="rId2"/>
+          <a:stretch>
+            <a:fillRect/>
+          </a:stretch>
+        </p:blipFill>
         <p:spPr>
           <a:xfrm>
-            <a:off x="640080" y="365760"/>
-            <a:ext cx="10972800" cy="822960"/>
+            <a:off x="0" y="0"/>
+            <a:ext cx="12191695" cy="6858000"/>
           </a:xfrm>
           <a:prstGeom prst="rect">
             <a:avLst/>
           </a:prstGeom>
-          <a:noFill/>
         </p:spPr>
-        <p:txBody>
-          <a:bodyPr wrap="none">
-            <a:spAutoFit/>
-          </a:bodyPr>
-          <a:lstStyle/>
-          <a:p>
-            <a:r>
-              <a:rPr sz="2800" b="1">
-                <a:solidFill>
-                  <a:srgbClr val="2D5A47"/>
-                </a:solidFill>
-                <a:latin typeface="Arial"/>
-              </a:rPr>
-              <a:t>2  </a:t>
-            </a:r>
-            <a:r>
-              <a:rPr sz="2800" b="1">
-                <a:solidFill>
-                  <a:srgbClr val="1A1A1A"/>
-                </a:solidFill>
-                <a:latin typeface="Arial"/>
-              </a:rPr>
-              <a:t>Komponenten &amp; Abhaengigkeiten</a:t>
-            </a:r>
-          </a:p>
-        </p:txBody>
-      </p:sp>
-      <p:sp>
-        <p:nvSpPr>
-          <p:cNvPr id="3" name="Rectangle 2"/>
-          <p:cNvSpPr/>
-          <p:nvPr/>
-        </p:nvSpPr>
-        <p:spPr>
-          <a:xfrm>
-            <a:off x="658368" y="1170432"/>
-            <a:ext cx="10893247" cy="25400"/>
-          </a:xfrm>
-          <a:prstGeom prst="rect">
-            <a:avLst/>
-          </a:prstGeom>
-          <a:solidFill>
-            <a:srgbClr val="2D5A47"/>
-          </a:solidFill>
-          <a:ln>
-            <a:noFill/>
-          </a:ln>
-        </p:spPr>
-        <p:style>
-          <a:lnRef idx="1">
-            <a:schemeClr val="accent1"/>
-          </a:lnRef>
-          <a:fillRef idx="3">
-            <a:schemeClr val="accent1"/>
-          </a:fillRef>
-          <a:effectRef idx="2">
-            <a:schemeClr val="accent1"/>
-          </a:effectRef>
-          <a:fontRef idx="minor">
-            <a:schemeClr val="lt1"/>
-          </a:fontRef>
-        </p:style>
-        <p:txBody>
-          <a:bodyPr rtlCol="0" anchor="ctr"/>
-          <a:lstStyle/>
-          <a:p>
-            <a:pPr algn="ctr"/>
-          </a:p>
-        </p:txBody>
-      </p:sp>
-      <p:sp>
-        <p:nvSpPr>
-          <p:cNvPr id="4" name="TextBox 3"/>
-          <p:cNvSpPr txBox="1"/>
-          <p:nvPr/>
-        </p:nvSpPr>
-        <p:spPr>
-          <a:xfrm>
-            <a:off x="685800" y="1417320"/>
-            <a:ext cx="10972800" cy="4754880"/>
-          </a:xfrm>
-          <a:prstGeom prst="rect">
-            <a:avLst/>
-          </a:prstGeom>
-          <a:noFill/>
-        </p:spPr>
-        <p:txBody>
-          <a:bodyPr wrap="square">
-            <a:spAutoFit/>
-          </a:bodyPr>
-          <a:lstStyle/>
-          <a:p>
-            <a:pPr>
-              <a:spcAft>
-                <a:spcPts val="700"/>
-              </a:spcAft>
-            </a:pPr>
-            <a:r>
-              <a:rPr sz="1800" b="1">
-                <a:solidFill>
-                  <a:srgbClr val="1A1A1A"/>
-                </a:solidFill>
-                <a:latin typeface="Arial"/>
-              </a:rPr>
-              <a:t>▪  Backend (de.eateasy.*)</a:t>
-            </a:r>
-          </a:p>
-          <a:p>
-            <a:pPr lvl="1">
-              <a:spcAft>
-                <a:spcPts val="700"/>
-              </a:spcAft>
-            </a:pPr>
-            <a:r>
-              <a:rPr sz="1600" b="0">
-                <a:solidFill>
-                  <a:srgbClr val="333333"/>
-                </a:solidFill>
-                <a:latin typeface="Arial"/>
-              </a:rPr>
-              <a:t>–  auth · household · recipe · ingredient · mealplan</a:t>
-            </a:r>
-          </a:p>
-          <a:p>
-            <a:pPr lvl="1">
-              <a:spcAft>
-                <a:spcPts val="700"/>
-              </a:spcAft>
-            </a:pPr>
-            <a:r>
-              <a:rPr sz="1600" b="0">
-                <a:solidFill>
-                  <a:srgbClr val="333333"/>
-                </a:solidFill>
-                <a:latin typeface="Arial"/>
-              </a:rPr>
-              <a:t>–  pantry · shoppinglist · suggestion · integration · notification · common</a:t>
-            </a:r>
-          </a:p>
-          <a:p>
-            <a:pPr>
-              <a:spcAft>
-                <a:spcPts val="700"/>
-              </a:spcAft>
-            </a:pPr>
-            <a:r>
-              <a:rPr sz="1800" b="1">
-                <a:solidFill>
-                  <a:srgbClr val="1A1A1A"/>
-                </a:solidFill>
-                <a:latin typeface="Arial"/>
-              </a:rPr>
-              <a:t>▪  Schichten je Komponente</a:t>
-            </a:r>
-          </a:p>
-          <a:p>
-            <a:pPr lvl="1">
-              <a:spcAft>
-                <a:spcPts val="700"/>
-              </a:spcAft>
-            </a:pPr>
-            <a:r>
-              <a:rPr sz="1600" b="0">
-                <a:solidFill>
-                  <a:srgbClr val="333333"/>
-                </a:solidFill>
-                <a:latin typeface="Arial"/>
-              </a:rPr>
-              <a:t>–  entity -&gt; repository -&gt; service (Interface+Impl) -&gt; resource -&gt; dto</a:t>
-            </a:r>
-          </a:p>
-          <a:p>
-            <a:pPr>
-              <a:spcAft>
-                <a:spcPts val="700"/>
-              </a:spcAft>
-            </a:pPr>
-            <a:r>
-              <a:rPr sz="1800" b="1">
-                <a:solidFill>
-                  <a:srgbClr val="1A1A1A"/>
-                </a:solidFill>
-                <a:latin typeface="Arial"/>
-              </a:rPr>
-              <a:t>▪  Abhaengigkeitsfluss</a:t>
-            </a:r>
-          </a:p>
-          <a:p>
-            <a:pPr lvl="1">
-              <a:spcAft>
-                <a:spcPts val="700"/>
-              </a:spcAft>
-            </a:pPr>
-            <a:r>
-              <a:rPr sz="1600" b="0">
-                <a:solidFill>
-                  <a:srgbClr val="333333"/>
-                </a:solidFill>
-                <a:latin typeface="Arial"/>
-              </a:rPr>
-              <a:t>–  auth -&gt; household -&gt; (recipe, pantry) -&gt; mealplan -&gt; shoppinglist -&gt; suggestion</a:t>
-            </a:r>
-          </a:p>
-          <a:p>
-            <a:pPr lvl="1">
-              <a:spcAft>
-                <a:spcPts val="700"/>
-              </a:spcAft>
-            </a:pPr>
-            <a:r>
-              <a:rPr sz="1600" b="0">
-                <a:solidFill>
-                  <a:srgbClr val="333333"/>
-                </a:solidFill>
-                <a:latin typeface="Arial"/>
-              </a:rPr>
-              <a:t>–  notification an household; integration speist recipe &amp; pantry</a:t>
-            </a:r>
-          </a:p>
-        </p:txBody>
-      </p:sp>
-      <p:sp>
-        <p:nvSpPr>
-          <p:cNvPr id="5" name="TextBox 4"/>
-          <p:cNvSpPr txBox="1"/>
-          <p:nvPr/>
-        </p:nvSpPr>
-        <p:spPr>
-          <a:xfrm>
-            <a:off x="640080" y="6400800"/>
-            <a:ext cx="5486400" cy="365760"/>
-          </a:xfrm>
-          <a:prstGeom prst="rect">
-            <a:avLst/>
-          </a:prstGeom>
-          <a:noFill/>
-        </p:spPr>
-        <p:txBody>
-          <a:bodyPr wrap="none">
-            <a:spAutoFit/>
-          </a:bodyPr>
-          <a:lstStyle/>
-          <a:p>
-            <a:r>
-              <a:rPr sz="900">
-                <a:solidFill>
-                  <a:srgbClr val="777777"/>
-                </a:solidFill>
-                <a:latin typeface="Arial"/>
-              </a:rPr>
-              <a:t>EatEasy EE — Architektur</a:t>
-            </a:r>
-          </a:p>
-        </p:txBody>
-      </p:sp>
-      <p:sp>
-        <p:nvSpPr>
-          <p:cNvPr id="6" name="TextBox 5"/>
-          <p:cNvSpPr txBox="1"/>
-          <p:nvPr/>
-        </p:nvSpPr>
-        <p:spPr>
-          <a:xfrm>
-            <a:off x="6400800" y="6400800"/>
-            <a:ext cx="5120640" cy="365760"/>
-          </a:xfrm>
-          <a:prstGeom prst="rect">
-            <a:avLst/>
-          </a:prstGeom>
-          <a:noFill/>
-        </p:spPr>
-        <p:txBody>
-          <a:bodyPr wrap="none">
-            <a:spAutoFit/>
-          </a:bodyPr>
-          <a:lstStyle/>
-          <a:p>
-            <a:pPr algn="r"/>
-            <a:r>
-              <a:rPr sz="900">
-                <a:solidFill>
-                  <a:srgbClr val="777777"/>
-                </a:solidFill>
-                <a:latin typeface="Arial"/>
-              </a:rPr>
-              <a:t>Folie 3 / 7</a:t>
-            </a:r>
-          </a:p>
-        </p:txBody>
-      </p:sp>
+      </p:pic>
     </p:spTree>
   </p:cSld>
   <p:clrMapOvr>
@@ -4050,1156 +3217,30 @@
         <p:nvPr/>
       </p:nvGrpSpPr>
       <p:grpSpPr/>
-      <p:sp>
-        <p:nvSpPr>
-          <p:cNvPr id="2" name="TextBox 1"/>
-          <p:cNvSpPr txBox="1"/>
+      <p:pic>
+        <p:nvPicPr>
+          <p:cNvPr id="2" name="Picture 1" descr="slide_4.png"/>
+          <p:cNvPicPr>
+            <a:picLocks noChangeAspect="1"/>
+          </p:cNvPicPr>
           <p:nvPr/>
-        </p:nvSpPr>
+        </p:nvPicPr>
+        <p:blipFill>
+          <a:blip r:embed="rId2"/>
+          <a:stretch>
+            <a:fillRect/>
+          </a:stretch>
+        </p:blipFill>
         <p:spPr>
           <a:xfrm>
-            <a:off x="640080" y="365760"/>
-            <a:ext cx="10972800" cy="822960"/>
+            <a:off x="0" y="0"/>
+            <a:ext cx="12191695" cy="6858000"/>
           </a:xfrm>
           <a:prstGeom prst="rect">
             <a:avLst/>
           </a:prstGeom>
-          <a:noFill/>
         </p:spPr>
-        <p:txBody>
-          <a:bodyPr wrap="none">
-            <a:spAutoFit/>
-          </a:bodyPr>
-          <a:lstStyle/>
-          <a:p>
-            <a:r>
-              <a:rPr sz="2800" b="1">
-                <a:solidFill>
-                  <a:srgbClr val="2D5A47"/>
-                </a:solidFill>
-                <a:latin typeface="Arial"/>
-              </a:rPr>
-              <a:t>3  </a:t>
-            </a:r>
-            <a:r>
-              <a:rPr sz="2800" b="1">
-                <a:solidFill>
-                  <a:srgbClr val="1A1A1A"/>
-                </a:solidFill>
-                <a:latin typeface="Arial"/>
-              </a:rPr>
-              <a:t>Genutzte Technologien</a:t>
-            </a:r>
-          </a:p>
-        </p:txBody>
-      </p:sp>
-      <p:sp>
-        <p:nvSpPr>
-          <p:cNvPr id="3" name="Rectangle 2"/>
-          <p:cNvSpPr/>
-          <p:nvPr/>
-        </p:nvSpPr>
-        <p:spPr>
-          <a:xfrm>
-            <a:off x="658368" y="1170432"/>
-            <a:ext cx="10893247" cy="25400"/>
-          </a:xfrm>
-          <a:prstGeom prst="rect">
-            <a:avLst/>
-          </a:prstGeom>
-          <a:solidFill>
-            <a:srgbClr val="2D5A47"/>
-          </a:solidFill>
-          <a:ln>
-            <a:noFill/>
-          </a:ln>
-        </p:spPr>
-        <p:style>
-          <a:lnRef idx="1">
-            <a:schemeClr val="accent1"/>
-          </a:lnRef>
-          <a:fillRef idx="3">
-            <a:schemeClr val="accent1"/>
-          </a:fillRef>
-          <a:effectRef idx="2">
-            <a:schemeClr val="accent1"/>
-          </a:effectRef>
-          <a:fontRef idx="minor">
-            <a:schemeClr val="lt1"/>
-          </a:fontRef>
-        </p:style>
-        <p:txBody>
-          <a:bodyPr rtlCol="0" anchor="ctr"/>
-          <a:lstStyle/>
-          <a:p>
-            <a:pPr algn="ctr"/>
-          </a:p>
-        </p:txBody>
-      </p:sp>
-      <p:sp>
-        <p:nvSpPr>
-          <p:cNvPr id="4" name="TextBox 3"/>
-          <p:cNvSpPr txBox="1"/>
-          <p:nvPr/>
-        </p:nvSpPr>
-        <p:spPr>
-          <a:xfrm>
-            <a:off x="685800" y="1417320"/>
-            <a:ext cx="10972800" cy="4754880"/>
-          </a:xfrm>
-          <a:prstGeom prst="rect">
-            <a:avLst/>
-          </a:prstGeom>
-          <a:noFill/>
-        </p:spPr>
-        <p:txBody>
-          <a:bodyPr wrap="square">
-            <a:spAutoFit/>
-          </a:bodyPr>
-          <a:lstStyle/>
-          <a:p>
-            <a:pPr>
-              <a:spcAft>
-                <a:spcPts val="700"/>
-              </a:spcAft>
-            </a:pPr>
-            <a:r>
-              <a:rPr sz="1800" b="1">
-                <a:solidFill>
-                  <a:srgbClr val="1A1A1A"/>
-                </a:solidFill>
-                <a:latin typeface="Arial"/>
-              </a:rPr>
-              <a:t>▪  Frontend: Vue 3, Vite, Pinia, Vue Router, TypeScript, Tailwind, VueUse</a:t>
-            </a:r>
-          </a:p>
-          <a:p>
-            <a:pPr>
-              <a:spcAft>
-                <a:spcPts val="700"/>
-              </a:spcAft>
-            </a:pPr>
-            <a:r>
-              <a:rPr sz="1800" b="1">
-                <a:solidFill>
-                  <a:srgbClr val="1A1A1A"/>
-                </a:solidFill>
-                <a:latin typeface="Arial"/>
-              </a:rPr>
-              <a:t>▪  Backend: Quarkus (Java 21), RESTEasy Reactive, Hibernate Panache, SmallRye JWT</a:t>
-            </a:r>
-          </a:p>
-          <a:p>
-            <a:pPr>
-              <a:spcAft>
-                <a:spcPts val="700"/>
-              </a:spcAft>
-            </a:pPr>
-            <a:r>
-              <a:rPr sz="1800" b="1">
-                <a:solidFill>
-                  <a:srgbClr val="1A1A1A"/>
-                </a:solidFill>
-                <a:latin typeface="Arial"/>
-              </a:rPr>
-              <a:t>▪  Datenbank: PostgreSQL 16 + Flyway</a:t>
-            </a:r>
-          </a:p>
-          <a:p>
-            <a:pPr>
-              <a:spcAft>
-                <a:spcPts val="700"/>
-              </a:spcAft>
-            </a:pPr>
-            <a:r>
-              <a:rPr sz="1800" b="1">
-                <a:solidFill>
-                  <a:srgbClr val="1A1A1A"/>
-                </a:solidFill>
-                <a:latin typeface="Arial"/>
-              </a:rPr>
-              <a:t>▪  LLM: Ollama self-hosted (Llama 3 / Mistral)</a:t>
-            </a:r>
-          </a:p>
-          <a:p>
-            <a:pPr>
-              <a:spcAft>
-                <a:spcPts val="700"/>
-              </a:spcAft>
-            </a:pPr>
-            <a:r>
-              <a:rPr sz="1800" b="1">
-                <a:solidFill>
-                  <a:srgbClr val="1A1A1A"/>
-                </a:solidFill>
-                <a:latin typeface="Arial"/>
-              </a:rPr>
-              <a:t>▪  Externe APIs: TheMealDB (Rezepte), OpenFoodFacts (Barcode)</a:t>
-            </a:r>
-          </a:p>
-          <a:p>
-            <a:pPr>
-              <a:spcAft>
-                <a:spcPts val="700"/>
-              </a:spcAft>
-            </a:pPr>
-            <a:r>
-              <a:rPr sz="1800" b="1">
-                <a:solidFill>
-                  <a:srgbClr val="1A1A1A"/>
-                </a:solidFill>
-                <a:latin typeface="Arial"/>
-              </a:rPr>
-              <a:t>▪  Testing: JUnit5 + REST Assured, Vitest + MSW, Playwright (E2E)</a:t>
-            </a:r>
-          </a:p>
-          <a:p>
-            <a:pPr>
-              <a:spcAft>
-                <a:spcPts val="700"/>
-              </a:spcAft>
-            </a:pPr>
-            <a:r>
-              <a:rPr sz="1800" b="1">
-                <a:solidFill>
-                  <a:srgbClr val="1A1A1A"/>
-                </a:solidFill>
-                <a:latin typeface="Arial"/>
-              </a:rPr>
-              <a:t>▪  Qualitaet/CI: Checkstyle, ESLint + Prettier, GitHub Actions</a:t>
-            </a:r>
-          </a:p>
-          <a:p>
-            <a:pPr>
-              <a:spcAft>
-                <a:spcPts val="700"/>
-              </a:spcAft>
-            </a:pPr>
-            <a:r>
-              <a:rPr sz="1800" b="1">
-                <a:solidFill>
-                  <a:srgbClr val="1A1A1A"/>
-                </a:solidFill>
-                <a:latin typeface="Arial"/>
-              </a:rPr>
-              <a:t>▪  Deployment: Render (Backend + DB), Vercel (Frontend, geplant)</a:t>
-            </a:r>
-          </a:p>
-        </p:txBody>
-      </p:sp>
-      <p:sp>
-        <p:nvSpPr>
-          <p:cNvPr id="5" name="TextBox 4"/>
-          <p:cNvSpPr txBox="1"/>
-          <p:nvPr/>
-        </p:nvSpPr>
-        <p:spPr>
-          <a:xfrm>
-            <a:off x="640080" y="6400800"/>
-            <a:ext cx="5486400" cy="365760"/>
-          </a:xfrm>
-          <a:prstGeom prst="rect">
-            <a:avLst/>
-          </a:prstGeom>
-          <a:noFill/>
-        </p:spPr>
-        <p:txBody>
-          <a:bodyPr wrap="none">
-            <a:spAutoFit/>
-          </a:bodyPr>
-          <a:lstStyle/>
-          <a:p>
-            <a:r>
-              <a:rPr sz="900">
-                <a:solidFill>
-                  <a:srgbClr val="777777"/>
-                </a:solidFill>
-                <a:latin typeface="Arial"/>
-              </a:rPr>
-              <a:t>EatEasy EE — Architektur</a:t>
-            </a:r>
-          </a:p>
-        </p:txBody>
-      </p:sp>
-      <p:sp>
-        <p:nvSpPr>
-          <p:cNvPr id="6" name="TextBox 5"/>
-          <p:cNvSpPr txBox="1"/>
-          <p:nvPr/>
-        </p:nvSpPr>
-        <p:spPr>
-          <a:xfrm>
-            <a:off x="6400800" y="6400800"/>
-            <a:ext cx="5120640" cy="365760"/>
-          </a:xfrm>
-          <a:prstGeom prst="rect">
-            <a:avLst/>
-          </a:prstGeom>
-          <a:noFill/>
-        </p:spPr>
-        <p:txBody>
-          <a:bodyPr wrap="none">
-            <a:spAutoFit/>
-          </a:bodyPr>
-          <a:lstStyle/>
-          <a:p>
-            <a:pPr algn="r"/>
-            <a:r>
-              <a:rPr sz="900">
-                <a:solidFill>
-                  <a:srgbClr val="777777"/>
-                </a:solidFill>
-                <a:latin typeface="Arial"/>
-              </a:rPr>
-              <a:t>Folie 4 / 7</a:t>
-            </a:r>
-          </a:p>
-        </p:txBody>
-      </p:sp>
-    </p:spTree>
-  </p:cSld>
-  <p:clrMapOvr>
-    <a:masterClrMapping/>
-  </p:clrMapOvr>
-</p:sld>
-</file>
-
-<file path=ppt/slides/slide5.xml><?xml version="1.0" encoding="utf-8"?>
-<p:sld xmlns:a="http://schemas.openxmlformats.org/drawingml/2006/main" xmlns:p="http://schemas.openxmlformats.org/presentationml/2006/main" xmlns:r="http://schemas.openxmlformats.org/officeDocument/2006/relationships">
-  <p:cSld>
-    <p:spTree>
-      <p:nvGrpSpPr>
-        <p:cNvPr id="1" name=""/>
-        <p:cNvGrpSpPr/>
-        <p:nvPr/>
-      </p:nvGrpSpPr>
-      <p:grpSpPr/>
-      <p:sp>
-        <p:nvSpPr>
-          <p:cNvPr id="2" name="TextBox 1"/>
-          <p:cNvSpPr txBox="1"/>
-          <p:nvPr/>
-        </p:nvSpPr>
-        <p:spPr>
-          <a:xfrm>
-            <a:off x="640080" y="365760"/>
-            <a:ext cx="10972800" cy="822960"/>
-          </a:xfrm>
-          <a:prstGeom prst="rect">
-            <a:avLst/>
-          </a:prstGeom>
-          <a:noFill/>
-        </p:spPr>
-        <p:txBody>
-          <a:bodyPr wrap="none">
-            <a:spAutoFit/>
-          </a:bodyPr>
-          <a:lstStyle/>
-          <a:p>
-            <a:r>
-              <a:rPr sz="2800" b="1">
-                <a:solidFill>
-                  <a:srgbClr val="2D5A47"/>
-                </a:solidFill>
-                <a:latin typeface="Arial"/>
-              </a:rPr>
-              <a:t>4  </a:t>
-            </a:r>
-            <a:r>
-              <a:rPr sz="2800" b="1">
-                <a:solidFill>
-                  <a:srgbClr val="1A1A1A"/>
-                </a:solidFill>
-                <a:latin typeface="Arial"/>
-              </a:rPr>
-              <a:t>Resilienz / Backup-Plan</a:t>
-            </a:r>
-          </a:p>
-        </p:txBody>
-      </p:sp>
-      <p:sp>
-        <p:nvSpPr>
-          <p:cNvPr id="3" name="Rectangle 2"/>
-          <p:cNvSpPr/>
-          <p:nvPr/>
-        </p:nvSpPr>
-        <p:spPr>
-          <a:xfrm>
-            <a:off x="658368" y="1170432"/>
-            <a:ext cx="10893247" cy="25400"/>
-          </a:xfrm>
-          <a:prstGeom prst="rect">
-            <a:avLst/>
-          </a:prstGeom>
-          <a:solidFill>
-            <a:srgbClr val="2D5A47"/>
-          </a:solidFill>
-          <a:ln>
-            <a:noFill/>
-          </a:ln>
-        </p:spPr>
-        <p:style>
-          <a:lnRef idx="1">
-            <a:schemeClr val="accent1"/>
-          </a:lnRef>
-          <a:fillRef idx="3">
-            <a:schemeClr val="accent1"/>
-          </a:fillRef>
-          <a:effectRef idx="2">
-            <a:schemeClr val="accent1"/>
-          </a:effectRef>
-          <a:fontRef idx="minor">
-            <a:schemeClr val="lt1"/>
-          </a:fontRef>
-        </p:style>
-        <p:txBody>
-          <a:bodyPr rtlCol="0" anchor="ctr"/>
-          <a:lstStyle/>
-          <a:p>
-            <a:pPr algn="ctr"/>
-          </a:p>
-        </p:txBody>
-      </p:sp>
-      <p:sp>
-        <p:nvSpPr>
-          <p:cNvPr id="4" name="TextBox 3"/>
-          <p:cNvSpPr txBox="1"/>
-          <p:nvPr/>
-        </p:nvSpPr>
-        <p:spPr>
-          <a:xfrm>
-            <a:off x="685800" y="1417320"/>
-            <a:ext cx="10972800" cy="4754880"/>
-          </a:xfrm>
-          <a:prstGeom prst="rect">
-            <a:avLst/>
-          </a:prstGeom>
-          <a:noFill/>
-        </p:spPr>
-        <p:txBody>
-          <a:bodyPr wrap="square">
-            <a:spAutoFit/>
-          </a:bodyPr>
-          <a:lstStyle/>
-          <a:p>
-            <a:pPr>
-              <a:spcAft>
-                <a:spcPts val="700"/>
-              </a:spcAft>
-            </a:pPr>
-            <a:r>
-              <a:rPr sz="1800" b="1">
-                <a:solidFill>
-                  <a:srgbClr val="1A1A1A"/>
-                </a:solidFill>
-                <a:latin typeface="Arial"/>
-              </a:rPr>
-              <a:t>▪  Smart-Suggestion: Ollama-Ausfall -&gt; Coverage-Heuristik</a:t>
-            </a:r>
-          </a:p>
-          <a:p>
-            <a:pPr>
-              <a:spcAft>
-                <a:spcPts val="700"/>
-              </a:spcAft>
-            </a:pPr>
-            <a:r>
-              <a:rPr sz="1800" b="1">
-                <a:solidFill>
-                  <a:srgbClr val="1A1A1A"/>
-                </a:solidFill>
-                <a:latin typeface="Arial"/>
-              </a:rPr>
-              <a:t>▪  Barcode-Scan: keine Kamera -&gt; manuelle Eingabe (optional)</a:t>
-            </a:r>
-          </a:p>
-          <a:p>
-            <a:pPr>
-              <a:spcAft>
-                <a:spcPts val="700"/>
-              </a:spcAft>
-            </a:pPr>
-            <a:r>
-              <a:rPr sz="1800" b="1">
-                <a:solidFill>
-                  <a:srgbClr val="1A1A1A"/>
-                </a:solidFill>
-                <a:latin typeface="Arial"/>
-              </a:rPr>
-              <a:t>▪  Rezept-Import: nur TheMealDB (kostenlos, kein API-Key)</a:t>
-            </a:r>
-          </a:p>
-          <a:p>
-            <a:pPr>
-              <a:spcAft>
-                <a:spcPts val="700"/>
-              </a:spcAft>
-            </a:pPr>
-            <a:r>
-              <a:rPr sz="1800" b="1">
-                <a:solidFill>
-                  <a:srgbClr val="1A1A1A"/>
-                </a:solidFill>
-                <a:latin typeface="Arial"/>
-              </a:rPr>
-              <a:t>▪  E-Mail: Invitation wird auch bei Mail-Fehler angelegt</a:t>
-            </a:r>
-          </a:p>
-        </p:txBody>
-      </p:sp>
-      <p:sp>
-        <p:nvSpPr>
-          <p:cNvPr id="5" name="TextBox 4"/>
-          <p:cNvSpPr txBox="1"/>
-          <p:nvPr/>
-        </p:nvSpPr>
-        <p:spPr>
-          <a:xfrm>
-            <a:off x="640080" y="6400800"/>
-            <a:ext cx="5486400" cy="365760"/>
-          </a:xfrm>
-          <a:prstGeom prst="rect">
-            <a:avLst/>
-          </a:prstGeom>
-          <a:noFill/>
-        </p:spPr>
-        <p:txBody>
-          <a:bodyPr wrap="none">
-            <a:spAutoFit/>
-          </a:bodyPr>
-          <a:lstStyle/>
-          <a:p>
-            <a:r>
-              <a:rPr sz="900">
-                <a:solidFill>
-                  <a:srgbClr val="777777"/>
-                </a:solidFill>
-                <a:latin typeface="Arial"/>
-              </a:rPr>
-              <a:t>EatEasy EE — Architektur</a:t>
-            </a:r>
-          </a:p>
-        </p:txBody>
-      </p:sp>
-      <p:sp>
-        <p:nvSpPr>
-          <p:cNvPr id="6" name="TextBox 5"/>
-          <p:cNvSpPr txBox="1"/>
-          <p:nvPr/>
-        </p:nvSpPr>
-        <p:spPr>
-          <a:xfrm>
-            <a:off x="6400800" y="6400800"/>
-            <a:ext cx="5120640" cy="365760"/>
-          </a:xfrm>
-          <a:prstGeom prst="rect">
-            <a:avLst/>
-          </a:prstGeom>
-          <a:noFill/>
-        </p:spPr>
-        <p:txBody>
-          <a:bodyPr wrap="none">
-            <a:spAutoFit/>
-          </a:bodyPr>
-          <a:lstStyle/>
-          <a:p>
-            <a:pPr algn="r"/>
-            <a:r>
-              <a:rPr sz="900">
-                <a:solidFill>
-                  <a:srgbClr val="777777"/>
-                </a:solidFill>
-                <a:latin typeface="Arial"/>
-              </a:rPr>
-              <a:t>Folie 5 / 7</a:t>
-            </a:r>
-          </a:p>
-        </p:txBody>
-      </p:sp>
-    </p:spTree>
-  </p:cSld>
-  <p:clrMapOvr>
-    <a:masterClrMapping/>
-  </p:clrMapOvr>
-</p:sld>
-</file>
-
-<file path=ppt/slides/slide6.xml><?xml version="1.0" encoding="utf-8"?>
-<p:sld xmlns:a="http://schemas.openxmlformats.org/drawingml/2006/main" xmlns:p="http://schemas.openxmlformats.org/presentationml/2006/main" xmlns:r="http://schemas.openxmlformats.org/officeDocument/2006/relationships">
-  <p:cSld>
-    <p:spTree>
-      <p:nvGrpSpPr>
-        <p:cNvPr id="1" name=""/>
-        <p:cNvGrpSpPr/>
-        <p:nvPr/>
-      </p:nvGrpSpPr>
-      <p:grpSpPr/>
-      <p:sp>
-        <p:nvSpPr>
-          <p:cNvPr id="2" name="TextBox 1"/>
-          <p:cNvSpPr txBox="1"/>
-          <p:nvPr/>
-        </p:nvSpPr>
-        <p:spPr>
-          <a:xfrm>
-            <a:off x="640080" y="365760"/>
-            <a:ext cx="10972800" cy="822960"/>
-          </a:xfrm>
-          <a:prstGeom prst="rect">
-            <a:avLst/>
-          </a:prstGeom>
-          <a:noFill/>
-        </p:spPr>
-        <p:txBody>
-          <a:bodyPr wrap="none">
-            <a:spAutoFit/>
-          </a:bodyPr>
-          <a:lstStyle/>
-          <a:p>
-            <a:r>
-              <a:rPr sz="2800" b="1">
-                <a:solidFill>
-                  <a:srgbClr val="2D5A47"/>
-                </a:solidFill>
-                <a:latin typeface="Arial"/>
-              </a:rPr>
-              <a:t>5  </a:t>
-            </a:r>
-            <a:r>
-              <a:rPr sz="2800" b="1">
-                <a:solidFill>
-                  <a:srgbClr val="1A1A1A"/>
-                </a:solidFill>
-                <a:latin typeface="Arial"/>
-              </a:rPr>
-              <a:t>Was wir noch planen (Issues #3–#8)</a:t>
-            </a:r>
-          </a:p>
-        </p:txBody>
-      </p:sp>
-      <p:sp>
-        <p:nvSpPr>
-          <p:cNvPr id="3" name="Rectangle 2"/>
-          <p:cNvSpPr/>
-          <p:nvPr/>
-        </p:nvSpPr>
-        <p:spPr>
-          <a:xfrm>
-            <a:off x="658368" y="1170432"/>
-            <a:ext cx="10893247" cy="25400"/>
-          </a:xfrm>
-          <a:prstGeom prst="rect">
-            <a:avLst/>
-          </a:prstGeom>
-          <a:solidFill>
-            <a:srgbClr val="2D5A47"/>
-          </a:solidFill>
-          <a:ln>
-            <a:noFill/>
-          </a:ln>
-        </p:spPr>
-        <p:style>
-          <a:lnRef idx="1">
-            <a:schemeClr val="accent1"/>
-          </a:lnRef>
-          <a:fillRef idx="3">
-            <a:schemeClr val="accent1"/>
-          </a:fillRef>
-          <a:effectRef idx="2">
-            <a:schemeClr val="accent1"/>
-          </a:effectRef>
-          <a:fontRef idx="minor">
-            <a:schemeClr val="lt1"/>
-          </a:fontRef>
-        </p:style>
-        <p:txBody>
-          <a:bodyPr rtlCol="0" anchor="ctr"/>
-          <a:lstStyle/>
-          <a:p>
-            <a:pPr algn="ctr"/>
-          </a:p>
-        </p:txBody>
-      </p:sp>
-      <p:sp>
-        <p:nvSpPr>
-          <p:cNvPr id="4" name="TextBox 3"/>
-          <p:cNvSpPr txBox="1"/>
-          <p:nvPr/>
-        </p:nvSpPr>
-        <p:spPr>
-          <a:xfrm>
-            <a:off x="685800" y="1417320"/>
-            <a:ext cx="10972800" cy="4754880"/>
-          </a:xfrm>
-          <a:prstGeom prst="rect">
-            <a:avLst/>
-          </a:prstGeom>
-          <a:noFill/>
-        </p:spPr>
-        <p:txBody>
-          <a:bodyPr wrap="square">
-            <a:spAutoFit/>
-          </a:bodyPr>
-          <a:lstStyle/>
-          <a:p>
-            <a:pPr>
-              <a:spcAft>
-                <a:spcPts val="700"/>
-              </a:spcAft>
-            </a:pPr>
-            <a:r>
-              <a:rPr sz="1800" b="1">
-                <a:solidFill>
-                  <a:srgbClr val="1A1A1A"/>
-                </a:solidFill>
-                <a:latin typeface="Arial"/>
-              </a:rPr>
-              <a:t>▪  #3 Auto-Haushalt bei Registrierung</a:t>
-            </a:r>
-          </a:p>
-          <a:p>
-            <a:pPr lvl="1">
-              <a:spcAft>
-                <a:spcPts val="700"/>
-              </a:spcAft>
-            </a:pPr>
-            <a:r>
-              <a:rPr sz="1600" b="0">
-                <a:solidFill>
-                  <a:srgbClr val="333333"/>
-                </a:solidFill>
-                <a:latin typeface="Arial"/>
-              </a:rPr>
-              <a:t>–  AuthService injiziert HouseholdService, eine @Transactional-Einheit</a:t>
-            </a:r>
-          </a:p>
-          <a:p>
-            <a:pPr>
-              <a:spcAft>
-                <a:spcPts val="700"/>
-              </a:spcAft>
-            </a:pPr>
-            <a:r>
-              <a:rPr sz="1800" b="1">
-                <a:solidFill>
-                  <a:srgbClr val="1A1A1A"/>
-                </a:solidFill>
-                <a:latin typeface="Arial"/>
-              </a:rPr>
-              <a:t>▪  #4 Rezept-Rating (1-5 Sterne) — einziger Schema-Eingriff (V8)</a:t>
-            </a:r>
-          </a:p>
-          <a:p>
-            <a:pPr>
-              <a:spcAft>
-                <a:spcPts val="700"/>
-              </a:spcAft>
-            </a:pPr>
-            <a:r>
-              <a:rPr sz="1800" b="1">
-                <a:solidFill>
-                  <a:srgbClr val="1A1A1A"/>
-                </a:solidFill>
-                <a:latin typeface="Arial"/>
-              </a:rPr>
-              <a:t>▪  #5 Einkaufsliste explizit gegen Vorrat pruefen vor Ausstellen</a:t>
-            </a:r>
-          </a:p>
-          <a:p>
-            <a:pPr>
-              <a:spcAft>
-                <a:spcPts val="700"/>
-              </a:spcAft>
-            </a:pPr>
-            <a:r>
-              <a:rPr sz="1800" b="1">
-                <a:solidFill>
-                  <a:srgbClr val="1A1A1A"/>
-                </a:solidFill>
-                <a:latin typeface="Arial"/>
-              </a:rPr>
-              <a:t>▪  #6 LLM-Modell verifizieren / leichteres Modell</a:t>
-            </a:r>
-          </a:p>
-          <a:p>
-            <a:pPr>
-              <a:spcAft>
-                <a:spcPts val="700"/>
-              </a:spcAft>
-            </a:pPr>
-            <a:r>
-              <a:rPr sz="1800" b="1">
-                <a:solidFill>
-                  <a:srgbClr val="1A1A1A"/>
-                </a:solidFill>
-                <a:latin typeface="Arial"/>
-              </a:rPr>
-              <a:t>▪  #7 Vercel-Deployment fuers Frontend</a:t>
-            </a:r>
-          </a:p>
-          <a:p>
-            <a:pPr>
-              <a:spcAft>
-                <a:spcPts val="700"/>
-              </a:spcAft>
-            </a:pPr>
-            <a:r>
-              <a:rPr sz="1800" b="1">
-                <a:solidFill>
-                  <a:srgbClr val="1A1A1A"/>
-                </a:solidFill>
-                <a:latin typeface="Arial"/>
-              </a:rPr>
-              <a:t>▪  #8 Backup-Plan, Abhaengigkeiten &amp; Scope dokumentieren</a:t>
-            </a:r>
-          </a:p>
-        </p:txBody>
-      </p:sp>
-      <p:sp>
-        <p:nvSpPr>
-          <p:cNvPr id="5" name="TextBox 4"/>
-          <p:cNvSpPr txBox="1"/>
-          <p:nvPr/>
-        </p:nvSpPr>
-        <p:spPr>
-          <a:xfrm>
-            <a:off x="640080" y="6400800"/>
-            <a:ext cx="5486400" cy="365760"/>
-          </a:xfrm>
-          <a:prstGeom prst="rect">
-            <a:avLst/>
-          </a:prstGeom>
-          <a:noFill/>
-        </p:spPr>
-        <p:txBody>
-          <a:bodyPr wrap="none">
-            <a:spAutoFit/>
-          </a:bodyPr>
-          <a:lstStyle/>
-          <a:p>
-            <a:r>
-              <a:rPr sz="900">
-                <a:solidFill>
-                  <a:srgbClr val="777777"/>
-                </a:solidFill>
-                <a:latin typeface="Arial"/>
-              </a:rPr>
-              <a:t>EatEasy EE — Architektur</a:t>
-            </a:r>
-          </a:p>
-        </p:txBody>
-      </p:sp>
-      <p:sp>
-        <p:nvSpPr>
-          <p:cNvPr id="6" name="TextBox 5"/>
-          <p:cNvSpPr txBox="1"/>
-          <p:nvPr/>
-        </p:nvSpPr>
-        <p:spPr>
-          <a:xfrm>
-            <a:off x="6400800" y="6400800"/>
-            <a:ext cx="5120640" cy="365760"/>
-          </a:xfrm>
-          <a:prstGeom prst="rect">
-            <a:avLst/>
-          </a:prstGeom>
-          <a:noFill/>
-        </p:spPr>
-        <p:txBody>
-          <a:bodyPr wrap="none">
-            <a:spAutoFit/>
-          </a:bodyPr>
-          <a:lstStyle/>
-          <a:p>
-            <a:pPr algn="r"/>
-            <a:r>
-              <a:rPr sz="900">
-                <a:solidFill>
-                  <a:srgbClr val="777777"/>
-                </a:solidFill>
-                <a:latin typeface="Arial"/>
-              </a:rPr>
-              <a:t>Folie 6 / 7</a:t>
-            </a:r>
-          </a:p>
-        </p:txBody>
-      </p:sp>
-    </p:spTree>
-  </p:cSld>
-  <p:clrMapOvr>
-    <a:masterClrMapping/>
-  </p:clrMapOvr>
-</p:sld>
-</file>
-
-<file path=ppt/slides/slide7.xml><?xml version="1.0" encoding="utf-8"?>
-<p:sld xmlns:a="http://schemas.openxmlformats.org/drawingml/2006/main" xmlns:p="http://schemas.openxmlformats.org/presentationml/2006/main" xmlns:r="http://schemas.openxmlformats.org/officeDocument/2006/relationships">
-  <p:cSld>
-    <p:spTree>
-      <p:nvGrpSpPr>
-        <p:cNvPr id="1" name=""/>
-        <p:cNvGrpSpPr/>
-        <p:nvPr/>
-      </p:nvGrpSpPr>
-      <p:grpSpPr/>
-      <p:sp>
-        <p:nvSpPr>
-          <p:cNvPr id="2" name="TextBox 1"/>
-          <p:cNvSpPr txBox="1"/>
-          <p:nvPr/>
-        </p:nvSpPr>
-        <p:spPr>
-          <a:xfrm>
-            <a:off x="640080" y="365760"/>
-            <a:ext cx="10972800" cy="822960"/>
-          </a:xfrm>
-          <a:prstGeom prst="rect">
-            <a:avLst/>
-          </a:prstGeom>
-          <a:noFill/>
-        </p:spPr>
-        <p:txBody>
-          <a:bodyPr wrap="none">
-            <a:spAutoFit/>
-          </a:bodyPr>
-          <a:lstStyle/>
-          <a:p>
-            <a:r>
-              <a:rPr sz="2800" b="1">
-                <a:solidFill>
-                  <a:srgbClr val="2D5A47"/>
-                </a:solidFill>
-                <a:latin typeface="Arial"/>
-              </a:rPr>
-              <a:t>6  </a:t>
-            </a:r>
-            <a:r>
-              <a:rPr sz="2800" b="1">
-                <a:solidFill>
-                  <a:srgbClr val="1A1A1A"/>
-                </a:solidFill>
-                <a:latin typeface="Arial"/>
-              </a:rPr>
-              <a:t>Kernaussage</a:t>
-            </a:r>
-          </a:p>
-        </p:txBody>
-      </p:sp>
-      <p:sp>
-        <p:nvSpPr>
-          <p:cNvPr id="3" name="Rectangle 2"/>
-          <p:cNvSpPr/>
-          <p:nvPr/>
-        </p:nvSpPr>
-        <p:spPr>
-          <a:xfrm>
-            <a:off x="658368" y="1170432"/>
-            <a:ext cx="10893247" cy="25400"/>
-          </a:xfrm>
-          <a:prstGeom prst="rect">
-            <a:avLst/>
-          </a:prstGeom>
-          <a:solidFill>
-            <a:srgbClr val="2D5A47"/>
-          </a:solidFill>
-          <a:ln>
-            <a:noFill/>
-          </a:ln>
-        </p:spPr>
-        <p:style>
-          <a:lnRef idx="1">
-            <a:schemeClr val="accent1"/>
-          </a:lnRef>
-          <a:fillRef idx="3">
-            <a:schemeClr val="accent1"/>
-          </a:fillRef>
-          <a:effectRef idx="2">
-            <a:schemeClr val="accent1"/>
-          </a:effectRef>
-          <a:fontRef idx="minor">
-            <a:schemeClr val="lt1"/>
-          </a:fontRef>
-        </p:style>
-        <p:txBody>
-          <a:bodyPr rtlCol="0" anchor="ctr"/>
-          <a:lstStyle/>
-          <a:p>
-            <a:pPr algn="ctr"/>
-          </a:p>
-        </p:txBody>
-      </p:sp>
-      <p:sp>
-        <p:nvSpPr>
-          <p:cNvPr id="4" name="TextBox 3"/>
-          <p:cNvSpPr txBox="1"/>
-          <p:nvPr/>
-        </p:nvSpPr>
-        <p:spPr>
-          <a:xfrm>
-            <a:off x="685800" y="1417320"/>
-            <a:ext cx="10972800" cy="4754880"/>
-          </a:xfrm>
-          <a:prstGeom prst="rect">
-            <a:avLst/>
-          </a:prstGeom>
-          <a:noFill/>
-        </p:spPr>
-        <p:txBody>
-          <a:bodyPr wrap="square">
-            <a:spAutoFit/>
-          </a:bodyPr>
-          <a:lstStyle/>
-          <a:p>
-            <a:pPr>
-              <a:spcAft>
-                <a:spcPts val="700"/>
-              </a:spcAft>
-            </a:pPr>
-            <a:r>
-              <a:rPr sz="1800" b="1">
-                <a:solidFill>
-                  <a:srgbClr val="1A1A1A"/>
-                </a:solidFill>
-                <a:latin typeface="Arial"/>
-              </a:rPr>
-              <a:t>▪  Architektur bleibt unveraendert stabil:</a:t>
-            </a:r>
-          </a:p>
-          <a:p>
-            <a:pPr lvl="1">
-              <a:spcAft>
-                <a:spcPts val="700"/>
-              </a:spcAft>
-            </a:pPr>
-            <a:r>
-              <a:rPr sz="1600" b="0">
-                <a:solidFill>
-                  <a:srgbClr val="333333"/>
-                </a:solidFill>
-                <a:latin typeface="Arial"/>
-              </a:rPr>
-              <a:t>–  Modularer Monolith, Service-Interfaces, strikte DTO-Trennung</a:t>
-            </a:r>
-          </a:p>
-          <a:p>
-            <a:pPr lvl="1">
-              <a:spcAft>
-                <a:spcPts val="700"/>
-              </a:spcAft>
-            </a:pPr>
-            <a:r>
-              <a:rPr sz="1600" b="0">
-                <a:solidFill>
-                  <a:srgbClr val="333333"/>
-                </a:solidFill>
-                <a:latin typeface="Arial"/>
-              </a:rPr>
-              <a:t>–  JWT + Service-Layer-Authz, Flyway, UUID</a:t>
-            </a:r>
-          </a:p>
-          <a:p>
-            <a:pPr>
-              <a:spcAft>
-                <a:spcPts val="700"/>
-              </a:spcAft>
-            </a:pPr>
-            <a:r>
-              <a:rPr sz="1800" b="1">
-                <a:solidFill>
-                  <a:srgbClr val="1A1A1A"/>
-                </a:solidFill>
-                <a:latin typeface="Arial"/>
-              </a:rPr>
-              <a:t>▪  Nur #4 (Rating) beruehrt das Datenmodell</a:t>
-            </a:r>
-          </a:p>
-          <a:p>
-            <a:pPr>
-              <a:spcAft>
-                <a:spcPts val="700"/>
-              </a:spcAft>
-            </a:pPr>
-            <a:r>
-              <a:rPr sz="1800" b="1">
-                <a:solidFill>
-                  <a:srgbClr val="1A1A1A"/>
-                </a:solidFill>
-                <a:latin typeface="Arial"/>
-              </a:rPr>
-              <a:t>▪  Alles andere ist Service-Logik, Config oder Deployment/Doku</a:t>
-            </a:r>
-          </a:p>
-        </p:txBody>
-      </p:sp>
-      <p:sp>
-        <p:nvSpPr>
-          <p:cNvPr id="5" name="TextBox 4"/>
-          <p:cNvSpPr txBox="1"/>
-          <p:nvPr/>
-        </p:nvSpPr>
-        <p:spPr>
-          <a:xfrm>
-            <a:off x="640080" y="6400800"/>
-            <a:ext cx="5486400" cy="365760"/>
-          </a:xfrm>
-          <a:prstGeom prst="rect">
-            <a:avLst/>
-          </a:prstGeom>
-          <a:noFill/>
-        </p:spPr>
-        <p:txBody>
-          <a:bodyPr wrap="none">
-            <a:spAutoFit/>
-          </a:bodyPr>
-          <a:lstStyle/>
-          <a:p>
-            <a:r>
-              <a:rPr sz="900">
-                <a:solidFill>
-                  <a:srgbClr val="777777"/>
-                </a:solidFill>
-                <a:latin typeface="Arial"/>
-              </a:rPr>
-              <a:t>EatEasy EE — Architektur</a:t>
-            </a:r>
-          </a:p>
-        </p:txBody>
-      </p:sp>
-      <p:sp>
-        <p:nvSpPr>
-          <p:cNvPr id="6" name="TextBox 5"/>
-          <p:cNvSpPr txBox="1"/>
-          <p:nvPr/>
-        </p:nvSpPr>
-        <p:spPr>
-          <a:xfrm>
-            <a:off x="6400800" y="6400800"/>
-            <a:ext cx="5120640" cy="365760"/>
-          </a:xfrm>
-          <a:prstGeom prst="rect">
-            <a:avLst/>
-          </a:prstGeom>
-          <a:noFill/>
-        </p:spPr>
-        <p:txBody>
-          <a:bodyPr wrap="none">
-            <a:spAutoFit/>
-          </a:bodyPr>
-          <a:lstStyle/>
-          <a:p>
-            <a:pPr algn="r"/>
-            <a:r>
-              <a:rPr sz="900">
-                <a:solidFill>
-                  <a:srgbClr val="777777"/>
-                </a:solidFill>
-                <a:latin typeface="Arial"/>
-              </a:rPr>
-              <a:t>Folie 7 / 7</a:t>
-            </a:r>
-          </a:p>
-        </p:txBody>
-      </p:sp>
+      </p:pic>
     </p:spTree>
   </p:cSld>
   <p:clrMapOvr>

</xml_diff>